<commit_message>
Ablauf je Termin sichtbar: Besprechung, Impuls, Aufgaben für zu Hause
- Trennfolien und Folie „Ablauf heute“ in allen Präsentationen
- Phasen-Kennzeichnung auf jeder Folie und in der Plattform
- Termin 2: Impulsfolien zum mpTu ergänzt
- Texte zu Schulversuch, VDI und Bienhaus: Kursseite, Spalte Material

Co-Authored-By: Claude Opus 5.5 <noreply@anthropic.com>
Claude-Session: https://claude.ai/code/session_01KjTLRV2ju5iuSRgoeZgmvB
</commit_message>
<xml_diff>
--- a/technikdidaktisches-kolloquium/praesentationen/TdK_Termin-4_Referat-und-Diskussion.pptx
+++ b/technikdidaktisches-kolloquium/praesentationen/TdK_Termin-4_Referat-und-Diskussion.pptx
@@ -12,9 +12,12 @@
     <p:sldId id="260" r:id="rId6"/>
     <p:sldId id="261" r:id="rId7"/>
     <p:sldId id="262" r:id="rId8"/>
+    <p:sldId id="263" r:id="rId9"/>
+    <p:sldId id="264" r:id="rId10"/>
+    <p:sldId id="265" r:id="rId11"/>
   </p:sldIdLst>
   <p:notesMasterIdLst>
-    <p:notesMasterId r:id="rId9"/>
+    <p:notesMasterId r:id="rId12"/>
   </p:notesMasterIdLst>
   <p:sldSz cx="12192000" cy="6858000"/>
   <p:notesSz cx="6858000" cy="12192000"/>
@@ -550,6 +553,94 @@
 </p:notes>
 </file>
 
+<file path=ppt/notesSlides/notesSlide10.xml><?xml version="1.0" encoding="utf-8"?>
+<p:notes xmlns:a="http://schemas.openxmlformats.org/drawingml/2006/main" xmlns:r="http://schemas.openxmlformats.org/officeDocument/2006/relationships" xmlns:p="http://schemas.openxmlformats.org/presentationml/2006/main">
+  <p:cSld>
+    <p:spTree>
+      <p:nvGrpSpPr>
+        <p:cNvPr id="1" name=""/>
+        <p:cNvGrpSpPr/>
+        <p:nvPr/>
+      </p:nvGrpSpPr>
+      <p:grpSpPr>
+        <a:xfrm>
+          <a:off x="0" y="0"/>
+          <a:ext cx="0" cy="0"/>
+          <a:chOff x="0" y="0"/>
+          <a:chExt cx="0" cy="0"/>
+        </a:xfrm>
+      </p:grpSpPr>
+      <p:sp>
+        <p:nvSpPr>
+          <p:cNvPr id="2" name="Slide Image Placeholder 1"/>
+          <p:cNvSpPr>
+            <a:spLocks noGrp="1" noRot="1" noChangeAspect="1"/>
+          </p:cNvSpPr>
+          <p:nvPr>
+            <p:ph type="sldImg"/>
+          </p:nvPr>
+        </p:nvSpPr>
+        <p:spPr/>
+      </p:sp>
+      <p:sp>
+        <p:nvSpPr>
+          <p:cNvPr id="3" name="Notes Placeholder 2"/>
+          <p:cNvSpPr>
+            <a:spLocks noGrp="1"/>
+          </p:cNvSpPr>
+          <p:nvPr>
+            <p:ph type="body" idx="1"/>
+          </p:nvPr>
+        </p:nvSpPr>
+        <p:spPr/>
+        <p:txBody>
+          <a:bodyPr/>
+          <a:lstStyle/>
+          <a:p>
+            <a:r>
+              <a:rPr lang="en-US" dirty="0"/>
+              <a:t/>
+            </a:r>
+            <a:endParaRPr lang="en-US" dirty="0"/>
+          </a:p>
+        </p:txBody>
+      </p:sp>
+      <p:sp>
+        <p:nvSpPr>
+          <p:cNvPr id="4" name="Slide Number Placeholder 3"/>
+          <p:cNvSpPr>
+            <a:spLocks noGrp="1"/>
+          </p:cNvSpPr>
+          <p:nvPr>
+            <p:ph type="sldNum" sz="quarter" idx="10"/>
+          </p:nvPr>
+        </p:nvSpPr>
+        <p:spPr/>
+        <p:txBody>
+          <a:bodyPr/>
+          <a:lstStyle/>
+          <a:p>
+            <a:fld id="{F7021451-1387-4CA6-816F-3879F97B5CBC}" type="slidenum">
+              <a:rPr lang="en-US"/>
+              <a:t>10</a:t>
+            </a:fld>
+            <a:endParaRPr lang="en-US"/>
+          </a:p>
+        </p:txBody>
+      </p:sp>
+    </p:spTree>
+    <p:extLst>
+      <p:ext uri="{BB962C8B-B14F-4D97-AF65-F5344CB8AC3E}">
+        <p14:creationId xmlns:p14="http://schemas.microsoft.com/office/powerpoint/2010/main" val="1024086991"/>
+      </p:ext>
+    </p:extLst>
+  </p:cSld>
+  <p:clrMapOvr>
+    <a:masterClrMapping/>
+  </p:clrMapOvr>
+</p:notes>
+</file>
+
 <file path=ppt/notesSlides/notesSlide2.xml><?xml version="1.0" encoding="utf-8"?>
 <p:notes xmlns:a="http://schemas.openxmlformats.org/drawingml/2006/main" xmlns:r="http://schemas.openxmlformats.org/officeDocument/2006/relationships" xmlns:p="http://schemas.openxmlformats.org/presentationml/2006/main">
   <p:cSld>
@@ -1060,6 +1151,182 @@
             <a:fld id="{F7021451-1387-4CA6-816F-3879F97B5CBC}" type="slidenum">
               <a:rPr lang="en-US"/>
               <a:t>7</a:t>
+            </a:fld>
+            <a:endParaRPr lang="en-US"/>
+          </a:p>
+        </p:txBody>
+      </p:sp>
+    </p:spTree>
+    <p:extLst>
+      <p:ext uri="{BB962C8B-B14F-4D97-AF65-F5344CB8AC3E}">
+        <p14:creationId xmlns:p14="http://schemas.microsoft.com/office/powerpoint/2010/main" val="1024086991"/>
+      </p:ext>
+    </p:extLst>
+  </p:cSld>
+  <p:clrMapOvr>
+    <a:masterClrMapping/>
+  </p:clrMapOvr>
+</p:notes>
+</file>
+
+<file path=ppt/notesSlides/notesSlide8.xml><?xml version="1.0" encoding="utf-8"?>
+<p:notes xmlns:a="http://schemas.openxmlformats.org/drawingml/2006/main" xmlns:r="http://schemas.openxmlformats.org/officeDocument/2006/relationships" xmlns:p="http://schemas.openxmlformats.org/presentationml/2006/main">
+  <p:cSld>
+    <p:spTree>
+      <p:nvGrpSpPr>
+        <p:cNvPr id="1" name=""/>
+        <p:cNvGrpSpPr/>
+        <p:nvPr/>
+      </p:nvGrpSpPr>
+      <p:grpSpPr>
+        <a:xfrm>
+          <a:off x="0" y="0"/>
+          <a:ext cx="0" cy="0"/>
+          <a:chOff x="0" y="0"/>
+          <a:chExt cx="0" cy="0"/>
+        </a:xfrm>
+      </p:grpSpPr>
+      <p:sp>
+        <p:nvSpPr>
+          <p:cNvPr id="2" name="Slide Image Placeholder 1"/>
+          <p:cNvSpPr>
+            <a:spLocks noGrp="1" noRot="1" noChangeAspect="1"/>
+          </p:cNvSpPr>
+          <p:nvPr>
+            <p:ph type="sldImg"/>
+          </p:nvPr>
+        </p:nvSpPr>
+        <p:spPr/>
+      </p:sp>
+      <p:sp>
+        <p:nvSpPr>
+          <p:cNvPr id="3" name="Notes Placeholder 2"/>
+          <p:cNvSpPr>
+            <a:spLocks noGrp="1"/>
+          </p:cNvSpPr>
+          <p:nvPr>
+            <p:ph type="body" idx="1"/>
+          </p:nvPr>
+        </p:nvSpPr>
+        <p:spPr/>
+        <p:txBody>
+          <a:bodyPr/>
+          <a:lstStyle/>
+          <a:p>
+            <a:r>
+              <a:rPr lang="en-US" dirty="0"/>
+              <a:t/>
+            </a:r>
+            <a:endParaRPr lang="en-US" dirty="0"/>
+          </a:p>
+        </p:txBody>
+      </p:sp>
+      <p:sp>
+        <p:nvSpPr>
+          <p:cNvPr id="4" name="Slide Number Placeholder 3"/>
+          <p:cNvSpPr>
+            <a:spLocks noGrp="1"/>
+          </p:cNvSpPr>
+          <p:nvPr>
+            <p:ph type="sldNum" sz="quarter" idx="10"/>
+          </p:nvPr>
+        </p:nvSpPr>
+        <p:spPr/>
+        <p:txBody>
+          <a:bodyPr/>
+          <a:lstStyle/>
+          <a:p>
+            <a:fld id="{F7021451-1387-4CA6-816F-3879F97B5CBC}" type="slidenum">
+              <a:rPr lang="en-US"/>
+              <a:t>8</a:t>
+            </a:fld>
+            <a:endParaRPr lang="en-US"/>
+          </a:p>
+        </p:txBody>
+      </p:sp>
+    </p:spTree>
+    <p:extLst>
+      <p:ext uri="{BB962C8B-B14F-4D97-AF65-F5344CB8AC3E}">
+        <p14:creationId xmlns:p14="http://schemas.microsoft.com/office/powerpoint/2010/main" val="1024086991"/>
+      </p:ext>
+    </p:extLst>
+  </p:cSld>
+  <p:clrMapOvr>
+    <a:masterClrMapping/>
+  </p:clrMapOvr>
+</p:notes>
+</file>
+
+<file path=ppt/notesSlides/notesSlide9.xml><?xml version="1.0" encoding="utf-8"?>
+<p:notes xmlns:a="http://schemas.openxmlformats.org/drawingml/2006/main" xmlns:r="http://schemas.openxmlformats.org/officeDocument/2006/relationships" xmlns:p="http://schemas.openxmlformats.org/presentationml/2006/main">
+  <p:cSld>
+    <p:spTree>
+      <p:nvGrpSpPr>
+        <p:cNvPr id="1" name=""/>
+        <p:cNvGrpSpPr/>
+        <p:nvPr/>
+      </p:nvGrpSpPr>
+      <p:grpSpPr>
+        <a:xfrm>
+          <a:off x="0" y="0"/>
+          <a:ext cx="0" cy="0"/>
+          <a:chOff x="0" y="0"/>
+          <a:chExt cx="0" cy="0"/>
+        </a:xfrm>
+      </p:grpSpPr>
+      <p:sp>
+        <p:nvSpPr>
+          <p:cNvPr id="2" name="Slide Image Placeholder 1"/>
+          <p:cNvSpPr>
+            <a:spLocks noGrp="1" noRot="1" noChangeAspect="1"/>
+          </p:cNvSpPr>
+          <p:nvPr>
+            <p:ph type="sldImg"/>
+          </p:nvPr>
+        </p:nvSpPr>
+        <p:spPr/>
+      </p:sp>
+      <p:sp>
+        <p:nvSpPr>
+          <p:cNvPr id="3" name="Notes Placeholder 2"/>
+          <p:cNvSpPr>
+            <a:spLocks noGrp="1"/>
+          </p:cNvSpPr>
+          <p:nvPr>
+            <p:ph type="body" idx="1"/>
+          </p:nvPr>
+        </p:nvSpPr>
+        <p:spPr/>
+        <p:txBody>
+          <a:bodyPr/>
+          <a:lstStyle/>
+          <a:p>
+            <a:r>
+              <a:rPr lang="en-US" dirty="0"/>
+              <a:t/>
+            </a:r>
+            <a:endParaRPr lang="en-US" dirty="0"/>
+          </a:p>
+        </p:txBody>
+      </p:sp>
+      <p:sp>
+        <p:nvSpPr>
+          <p:cNvPr id="4" name="Slide Number Placeholder 3"/>
+          <p:cNvSpPr>
+            <a:spLocks noGrp="1"/>
+          </p:cNvSpPr>
+          <p:nvPr>
+            <p:ph type="sldNum" sz="quarter" idx="10"/>
+          </p:nvPr>
+        </p:nvSpPr>
+        <p:spPr/>
+        <p:txBody>
+          <a:bodyPr/>
+          <a:lstStyle/>
+          <a:p>
+            <a:fld id="{F7021451-1387-4CA6-816F-3879F97B5CBC}" type="slidenum">
+              <a:rPr lang="en-US"/>
+              <a:t>9</a:t>
             </a:fld>
             <a:endParaRPr lang="en-US"/>
           </a:p>
@@ -1164,8 +1431,8 @@
         </p:nvSpPr>
         <p:spPr>
           <a:xfrm>
-            <a:off x="5029200" y="201168"/>
-            <a:ext cx="6720840" cy="457200"/>
+            <a:off x="2926080" y="201168"/>
+            <a:ext cx="5852160" cy="457200"/>
           </a:xfrm>
           <a:prstGeom prst="rect">
             <a:avLst/>
@@ -1305,6 +1572,118 @@
 </file>
 
 <file path=ppt/slideLayouts/slideLayout3.xml><?xml version="1.0" encoding="utf-8"?>
+<p:sldLayout xmlns:a="http://schemas.openxmlformats.org/drawingml/2006/main" xmlns:r="http://schemas.openxmlformats.org/officeDocument/2006/relationships" xmlns:p="http://schemas.openxmlformats.org/presentationml/2006/main" preserve="1">
+  <p:cSld name="TRENNER">
+    <p:bg>
+      <p:bgPr>
+        <a:solidFill>
+          <a:srgbClr val="FFFFFF"/>
+        </a:solidFill>
+      </p:bgPr>
+    </p:bg>
+    <p:spTree>
+      <p:nvGrpSpPr>
+        <p:cNvPr id="1" name=""/>
+        <p:cNvGrpSpPr/>
+        <p:nvPr/>
+      </p:nvGrpSpPr>
+      <p:grpSpPr>
+        <a:xfrm>
+          <a:off x="0" y="0"/>
+          <a:ext cx="0" cy="0"/>
+          <a:chOff x="0" y="0"/>
+          <a:chExt cx="0" cy="0"/>
+        </a:xfrm>
+      </p:grpSpPr>
+      <p:sp>
+        <p:nvSpPr>
+          <p:cNvPr id="2" name="Shape 0"/>
+          <p:cNvSpPr/>
+          <p:nvPr/>
+        </p:nvSpPr>
+        <p:spPr>
+          <a:xfrm>
+            <a:off x="685800" y="274320"/>
+            <a:ext cx="1920240" cy="603504"/>
+          </a:xfrm>
+          <a:prstGeom prst="rect">
+            <a:avLst/>
+          </a:prstGeom>
+          <a:solidFill>
+            <a:srgbClr val="FFFFFF"/>
+          </a:solidFill>
+          <a:ln/>
+        </p:spPr>
+      </p:sp>
+      <p:pic>
+        <p:nvPicPr>
+          <p:cNvPr id="3" name="Image 0" descr="/tmp/claude-0/-home-claude/f0df0622-abb2-5c0a-a841-b1a0cebc56b9/scratchpad/pptx/logo.png">    </p:cNvPr>
+          <p:cNvPicPr>
+            <a:picLocks noChangeAspect="1"/>
+          </p:cNvPicPr>
+          <p:nvPr/>
+        </p:nvPicPr>
+        <p:blipFill>
+          <a:blip r:embed="rId1"/>
+          <a:stretch>
+            <a:fillRect/>
+          </a:stretch>
+        </p:blipFill>
+        <p:spPr>
+          <a:xfrm>
+            <a:off x="777240" y="329184"/>
+            <a:ext cx="1737360" cy="493776"/>
+          </a:xfrm>
+          <a:prstGeom prst="rect">
+            <a:avLst/>
+          </a:prstGeom>
+        </p:spPr>
+      </p:pic>
+      <p:sp>
+        <p:nvSpPr>
+          <p:cNvPr id="4" name="Text 1"/>
+          <p:cNvSpPr/>
+          <p:nvPr/>
+        </p:nvSpPr>
+        <p:spPr>
+          <a:xfrm>
+            <a:off x="548640" y="6400800"/>
+            <a:ext cx="9144000" cy="274320"/>
+          </a:xfrm>
+          <a:prstGeom prst="rect">
+            <a:avLst/>
+          </a:prstGeom>
+          <a:noFill/>
+          <a:ln/>
+        </p:spPr>
+        <p:txBody>
+          <a:bodyPr wrap="square" lIns="0" tIns="0" rIns="0" bIns="0" rtlCol="0" anchor="ctr"/>
+          <a:lstStyle/>
+          <a:p>
+            <a:pPr indent="0" marL="0">
+              <a:buNone/>
+            </a:pPr>
+            <a:r>
+              <a:rPr lang="en-US" sz="1000" dirty="0">
+                <a:solidFill>
+                  <a:srgbClr val="56687A"/>
+                </a:solidFill>
+              </a:rPr>
+              <a:t>Daniel Beyrodt · Universität Hildesheim · WiSe 2026/27 · CC BY-NC-SA 4.0</a:t>
+            </a:r>
+            <a:endParaRPr lang="en-US" sz="1000" dirty="0"/>
+          </a:p>
+        </p:txBody>
+      </p:sp>
+    </p:spTree>
+  </p:cSld>
+  <p:clrMapOvr>
+    <a:masterClrMapping/>
+  </p:clrMapOvr>
+</p:sldLayout>
+</file>
+
+<file path=ppt/slideLayouts/slideLayout4.xml><?xml version="1.0" encoding="utf-8"?>
 <p:sldLayout xmlns:a="http://schemas.openxmlformats.org/drawingml/2006/main" xmlns:r="http://schemas.openxmlformats.org/officeDocument/2006/relationships" xmlns:p="http://schemas.openxmlformats.org/presentationml/2006/main" preserve="1">
   <p:cSld name="TITEL">
     <p:bg>
@@ -1485,6 +1864,7 @@
     <p:sldLayoutId id="2147483649" r:id="rId1"/>
     <p:sldLayoutId id="2147483650" r:id="rId2"/>
     <p:sldLayoutId id="2147483651" r:id="rId3"/>
+    <p:sldLayoutId id="2147483652" r:id="rId4"/>
   </p:sldLayoutIdLst>
   <p:hf sldNum="0" hdr="0" ftr="0" dt="0"/>
   <p:txStyles>
@@ -1759,7 +2139,7 @@
       </p:grpSpPr>
       <p:sp>
         <p:nvSpPr>
-          <p:cNvPr id="2" name="titel-254"/>
+          <p:cNvPr id="2" name="titel-352"/>
           <p:cNvSpPr txBox="1"/>
           <p:nvPr/>
         </p:nvSpPr>
@@ -1795,7 +2175,7 @@
       </p:sp>
       <p:sp>
         <p:nvSpPr>
-          <p:cNvPr id="3" name="text-255"/>
+          <p:cNvPr id="3" name="text-353"/>
           <p:cNvSpPr txBox="1"/>
           <p:nvPr/>
         </p:nvSpPr>
@@ -1831,7 +2211,7 @@
       </p:sp>
       <p:sp>
         <p:nvSpPr>
-          <p:cNvPr id="4" name="box-256"/>
+          <p:cNvPr id="4" name="box-354"/>
           <p:cNvSpPr txBox="1"/>
           <p:nvPr/>
         </p:nvSpPr>
@@ -1869,7 +2249,7 @@
       </p:sp>
       <p:sp>
         <p:nvSpPr>
-          <p:cNvPr id="5" name="text-257"/>
+          <p:cNvPr id="5" name="text-355"/>
           <p:cNvSpPr txBox="1"/>
           <p:nvPr/>
         </p:nvSpPr>
@@ -1905,7 +2285,7 @@
       </p:sp>
       <p:sp>
         <p:nvSpPr>
-          <p:cNvPr id="6" name="box-258"/>
+          <p:cNvPr id="6" name="box-356"/>
           <p:cNvSpPr txBox="1"/>
           <p:nvPr/>
         </p:nvSpPr>
@@ -1943,7 +2323,7 @@
       </p:sp>
       <p:sp>
         <p:nvSpPr>
-          <p:cNvPr id="7" name="text-259"/>
+          <p:cNvPr id="7" name="text-357"/>
           <p:cNvSpPr txBox="1"/>
           <p:nvPr/>
         </p:nvSpPr>
@@ -1979,7 +2359,7 @@
       </p:sp>
       <p:sp>
         <p:nvSpPr>
-          <p:cNvPr id="8" name="box-260"/>
+          <p:cNvPr id="8" name="box-358"/>
           <p:cNvSpPr txBox="1"/>
           <p:nvPr/>
         </p:nvSpPr>
@@ -2017,7 +2397,7 @@
       </p:sp>
       <p:sp>
         <p:nvSpPr>
-          <p:cNvPr id="9" name="text-261"/>
+          <p:cNvPr id="9" name="text-359"/>
           <p:cNvSpPr txBox="1"/>
           <p:nvPr/>
         </p:nvSpPr>
@@ -2053,7 +2433,7 @@
       </p:sp>
       <p:sp>
         <p:nvSpPr>
-          <p:cNvPr id="10" name="box-262"/>
+          <p:cNvPr id="10" name="box-360"/>
           <p:cNvSpPr txBox="1"/>
           <p:nvPr/>
         </p:nvSpPr>
@@ -2091,7 +2471,7 @@
       </p:sp>
       <p:sp>
         <p:nvSpPr>
-          <p:cNvPr id="11" name="text-263"/>
+          <p:cNvPr id="11" name="text-361"/>
           <p:cNvSpPr txBox="1"/>
           <p:nvPr/>
         </p:nvSpPr>
@@ -2122,6 +2502,382 @@
               <a:t>Referat oder Vortrag und Diskussion</a:t>
             </a:r>
             <a:endParaRPr lang="en-US" sz="2200" dirty="0"/>
+          </a:p>
+        </p:txBody>
+      </p:sp>
+    </p:spTree>
+  </p:cSld>
+  <p:clrMapOvr>
+    <a:masterClrMapping/>
+  </p:clrMapOvr>
+</p:sld>
+</file>
+
+<file path=ppt/slides/slide10.xml><?xml version="1.0" encoding="utf-8"?>
+<p:sld xmlns:a="http://schemas.openxmlformats.org/drawingml/2006/main" xmlns:r="http://schemas.openxmlformats.org/officeDocument/2006/relationships" xmlns:p="http://schemas.openxmlformats.org/presentationml/2006/main">
+  <p:cSld name="Slide 10">
+    <p:spTree>
+      <p:nvGrpSpPr>
+        <p:cNvPr id="1" name=""/>
+        <p:cNvGrpSpPr/>
+        <p:nvPr/>
+      </p:nvGrpSpPr>
+      <p:grpSpPr>
+        <a:xfrm>
+          <a:off x="0" y="0"/>
+          <a:ext cx="0" cy="0"/>
+          <a:chOff x="0" y="0"/>
+          <a:chExt cx="0" cy="0"/>
+        </a:xfrm>
+      </p:grpSpPr>
+      <p:sp>
+        <p:nvSpPr>
+          <p:cNvPr id="2" name="box-411"/>
+          <p:cNvSpPr txBox="1"/>
+          <p:nvPr/>
+        </p:nvSpPr>
+        <p:spPr>
+          <a:xfrm>
+            <a:off x="8915400" y="246888"/>
+            <a:ext cx="2862072" cy="384048"/>
+          </a:xfrm>
+          <a:prstGeom prst="rect">
+            <a:avLst/>
+          </a:prstGeom>
+          <a:solidFill>
+            <a:srgbClr val="F5B700"/>
+          </a:solidFill>
+          <a:ln/>
+        </p:spPr>
+        <p:txBody>
+          <a:bodyPr wrap="square" lIns="25400" tIns="25400" rIns="25400" bIns="25400" rtlCol="0" anchor="ctr"/>
+          <a:lstStyle/>
+          <a:p>
+            <a:pPr algn="ctr" indent="0" marL="0">
+              <a:buNone/>
+            </a:pPr>
+            <a:r>
+              <a:rPr lang="en-US" sz="1400" b="1" dirty="0">
+                <a:solidFill>
+                  <a:srgbClr val="14232F"/>
+                </a:solidFill>
+              </a:rPr>
+              <a:t>Aufgaben für zu Hause</a:t>
+            </a:r>
+            <a:endParaRPr lang="en-US" sz="1400" dirty="0"/>
+          </a:p>
+        </p:txBody>
+      </p:sp>
+      <p:sp>
+        <p:nvSpPr>
+          <p:cNvPr id="3" name="titel-412"/>
+          <p:cNvSpPr txBox="1"/>
+          <p:nvPr/>
+        </p:nvSpPr>
+        <p:spPr>
+          <a:xfrm>
+            <a:off x="548640" y="896112"/>
+            <a:ext cx="11094415" cy="640080"/>
+          </a:xfrm>
+          <a:prstGeom prst="rect">
+            <a:avLst/>
+          </a:prstGeom>
+          <a:noFill/>
+          <a:ln/>
+        </p:spPr>
+        <p:txBody>
+          <a:bodyPr wrap="square" lIns="0" tIns="0" rIns="0" bIns="0" rtlCol="0" anchor="ctr"/>
+          <a:lstStyle/>
+          <a:p>
+            <a:pPr indent="0" marL="0">
+              <a:buNone/>
+            </a:pPr>
+            <a:r>
+              <a:rPr lang="en-US" sz="2800" b="1" dirty="0">
+                <a:solidFill>
+                  <a:srgbClr val="14232F"/>
+                </a:solidFill>
+              </a:rPr>
+              <a:t>Nach Termin 4: Ausarbeitung</a:t>
+            </a:r>
+            <a:endParaRPr lang="en-US" sz="2800" dirty="0"/>
+          </a:p>
+        </p:txBody>
+      </p:sp>
+      <p:sp>
+        <p:nvSpPr>
+          <p:cNvPr id="4" name="tile-413"/>
+          <p:cNvSpPr txBox="1"/>
+          <p:nvPr/>
+        </p:nvSpPr>
+        <p:spPr>
+          <a:xfrm>
+            <a:off x="548640" y="1600200"/>
+            <a:ext cx="5440680" cy="2011680"/>
+          </a:xfrm>
+          <a:prstGeom prst="rect">
+            <a:avLst/>
+          </a:prstGeom>
+          <a:solidFill>
+            <a:srgbClr val="FFF3C9"/>
+          </a:solidFill>
+          <a:ln w="6350">
+            <a:solidFill>
+              <a:srgbClr val="FFF3C9"/>
+            </a:solidFill>
+          </a:ln>
+        </p:spPr>
+        <p:txBody>
+          <a:bodyPr wrap="square" lIns="127000" tIns="127000" rIns="127000" bIns="127000" rtlCol="0" anchor="t"/>
+          <a:lstStyle/>
+          <a:p>
+            <a:pPr indent="0" marL="0">
+              <a:buNone/>
+            </a:pPr>
+            <a:r>
+              <a:rPr lang="en-US" sz="2200" b="1" dirty="0">
+                <a:solidFill>
+                  <a:srgbClr val="035591"/>
+                </a:solidFill>
+              </a:rPr>
+              <a:t>Weg A · Referat</a:t>
+            </a:r>
+            <a:endParaRPr lang="en-US" sz="2200" dirty="0"/>
+          </a:p>
+          <a:p>
+            <a:pPr indent="0" marL="0">
+              <a:spcBef>
+                <a:spcPts val="400"/>
+              </a:spcBef>
+              <a:buNone/>
+            </a:pPr>
+            <a:r>
+              <a:rPr lang="en-US" sz="1900" dirty="0">
+                <a:solidFill>
+                  <a:srgbClr val="14232F"/>
+                </a:solidFill>
+              </a:rPr>
+              <a:t>Ausarbeitung mit Diskussionsergebnissen und Ausblick (über 10 Seiten) – Abgabe zum Ende des Semesters</a:t>
+            </a:r>
+            <a:endParaRPr lang="en-US" sz="2200" dirty="0"/>
+          </a:p>
+        </p:txBody>
+      </p:sp>
+      <p:sp>
+        <p:nvSpPr>
+          <p:cNvPr id="5" name="tile-414"/>
+          <p:cNvSpPr txBox="1"/>
+          <p:nvPr/>
+        </p:nvSpPr>
+        <p:spPr>
+          <a:xfrm>
+            <a:off x="6199632" y="1600200"/>
+            <a:ext cx="5440680" cy="2011680"/>
+          </a:xfrm>
+          <a:prstGeom prst="rect">
+            <a:avLst/>
+          </a:prstGeom>
+          <a:solidFill>
+            <a:srgbClr val="E2F4E8"/>
+          </a:solidFill>
+          <a:ln w="6350">
+            <a:solidFill>
+              <a:srgbClr val="E2F4E8"/>
+            </a:solidFill>
+          </a:ln>
+        </p:spPr>
+        <p:txBody>
+          <a:bodyPr wrap="square" lIns="127000" tIns="127000" rIns="127000" bIns="127000" rtlCol="0" anchor="t"/>
+          <a:lstStyle/>
+          <a:p>
+            <a:pPr indent="0" marL="0">
+              <a:buNone/>
+            </a:pPr>
+            <a:r>
+              <a:rPr lang="en-US" sz="2200" b="1" dirty="0">
+                <a:solidFill>
+                  <a:srgbClr val="035591"/>
+                </a:solidFill>
+              </a:rPr>
+              <a:t>Weg B · Vortrag</a:t>
+            </a:r>
+            <a:endParaRPr lang="en-US" sz="2200" dirty="0"/>
+          </a:p>
+          <a:p>
+            <a:pPr indent="0" marL="0">
+              <a:spcBef>
+                <a:spcPts val="400"/>
+              </a:spcBef>
+              <a:buNone/>
+            </a:pPr>
+            <a:r>
+              <a:rPr lang="en-US" sz="1900" dirty="0">
+                <a:solidFill>
+                  <a:srgbClr val="14232F"/>
+                </a:solidFill>
+              </a:rPr>
+              <a:t>keine Ausarbeitung – Diskussionsergebnisse kurz festhalten</a:t>
+            </a:r>
+            <a:endParaRPr lang="en-US" sz="2200" dirty="0"/>
+          </a:p>
+        </p:txBody>
+      </p:sp>
+      <p:sp>
+        <p:nvSpPr>
+          <p:cNvPr id="6" name="link-415"/>
+          <p:cNvSpPr txBox="1"/>
+          <p:nvPr/>
+        </p:nvSpPr>
+        <p:spPr>
+          <a:xfrm>
+            <a:off x="548640" y="3931920"/>
+            <a:ext cx="7132320" cy="640080"/>
+          </a:xfrm>
+          <a:prstGeom prst="rect">
+            <a:avLst/>
+          </a:prstGeom>
+          <a:noFill/>
+          <a:ln/>
+        </p:spPr>
+        <p:txBody>
+          <a:bodyPr wrap="square" lIns="38100" tIns="38100" rIns="38100" bIns="38100" rtlCol="0" anchor="ctr"/>
+          <a:lstStyle/>
+          <a:p>
+            <a:pPr indent="0" marL="0">
+              <a:buNone/>
+            </a:pPr>
+            <a:r>
+              <a:rPr lang="en-US" sz="3000" dirty="0">
+                <a:solidFill>
+                  <a:srgbClr val="14232F"/>
+                </a:solidFill>
+              </a:rPr>
+              <a:t>Kursseite: </a:t>
+            </a:r>
+            <a:pPr indent="0" marL="0">
+              <a:buNone/>
+            </a:pPr>
+            <a:r>
+              <a:rPr lang="en-US" sz="3000" b="1" u="sng" dirty="0">
+                <a:solidFill>
+                  <a:srgbClr val="035591"/>
+                </a:solidFill>
+                <a:hlinkClick r:id="rId1" invalidUrl="" action="" tgtFrame="" tooltip="" history="1" highlightClick="0" endSnd="0">
+                  <a:extLst>
+                    <a:ext uri="{A12FA001-AC4F-418D-AE19-62706E023703}">
+                      <ahyp:hlinkClr xmlns:ahyp="http://schemas.microsoft.com/office/drawing/2018/hyperlinkcolor" val="tx"/>
+                    </a:ext>
+                  </a:extLst>
+                </a:hlinkClick>
+              </a:rPr>
+              <a:t>https://t1p.de/tdk-26</a:t>
+            </a:r>
+            <a:endParaRPr lang="en-US" sz="3000" dirty="0"/>
+          </a:p>
+        </p:txBody>
+      </p:sp>
+      <p:sp>
+        <p:nvSpPr>
+          <p:cNvPr id="7" name="text-416"/>
+          <p:cNvSpPr txBox="1"/>
+          <p:nvPr/>
+        </p:nvSpPr>
+        <p:spPr>
+          <a:xfrm>
+            <a:off x="548640" y="4663440"/>
+            <a:ext cx="7132320" cy="822960"/>
+          </a:xfrm>
+          <a:prstGeom prst="rect">
+            <a:avLst/>
+          </a:prstGeom>
+          <a:noFill/>
+          <a:ln/>
+        </p:spPr>
+        <p:txBody>
+          <a:bodyPr wrap="square" lIns="38100" tIns="38100" rIns="38100" bIns="38100" rtlCol="0" anchor="t"/>
+          <a:lstStyle/>
+          <a:p>
+            <a:pPr algn="l" indent="0" marL="0">
+              <a:buNone/>
+            </a:pPr>
+            <a:r>
+              <a:rPr lang="en-US" sz="2000" dirty="0">
+                <a:solidFill>
+                  <a:srgbClr val="14232F"/>
+                </a:solidFill>
+              </a:rPr>
+              <a:t>Aufgabenpaket 4: Diskussionsergebnisse, Ausblick, Gliederung</a:t>
+            </a:r>
+            <a:endParaRPr lang="en-US" sz="2000" dirty="0"/>
+          </a:p>
+        </p:txBody>
+      </p:sp>
+      <p:pic>
+        <p:nvPicPr>
+          <p:cNvPr id="8" name="qr-417" descr="QR-Code zur Kursseite: https://t1p.de/tdk-26">    </p:cNvPr>
+          <p:cNvPicPr>
+            <a:picLocks noChangeAspect="1"/>
+          </p:cNvPicPr>
+          <p:nvPr/>
+        </p:nvPicPr>
+        <p:blipFill>
+          <a:blip r:embed="rId2"/>
+          <a:stretch>
+            <a:fillRect/>
+          </a:stretch>
+        </p:blipFill>
+        <p:spPr>
+          <a:xfrm>
+            <a:off x="9098280" y="3703320"/>
+            <a:ext cx="2103120" cy="2103120"/>
+          </a:xfrm>
+          <a:prstGeom prst="rect">
+            <a:avLst/>
+          </a:prstGeom>
+        </p:spPr>
+      </p:pic>
+      <p:sp>
+        <p:nvSpPr>
+          <p:cNvPr id="25" name="Slide Number Placeholder 0"/>
+          <p:cNvSpPr>
+            <a:spLocks noGrp="1"/>
+          </p:cNvSpPr>
+          <p:nvPr>
+            <p:ph type="sldNum" sz="quarter" idx="4294967295"/>
+          </p:nvPr>
+        </p:nvSpPr>
+        <p:spPr>
+          <a:xfrm>
+            <a:off x="11247120" y="6473952"/>
+            <a:ext cx="548640" cy="274320"/>
+          </a:xfrm>
+          <a:prstGeom prst="rect">
+            <a:avLst/>
+          </a:prstGeom>
+          <a:extLst>
+            <a:ext uri="{C572A759-6A51-4108-AA02-DFA0A04FC94B}">
+              <ma14:wrappingTextBoxFlag xmlns:ma14="http://schemas.microsoft.com/office/mac/drawingml/2011/main" val="0"/>
+            </a:ext>
+          </a:extLst>
+        </p:spPr>
+        <p:txBody>
+          <a:bodyPr/>
+          <a:lstStyle>
+            <a:lvl1pPr>
+              <a:defRPr sz="1000">
+                <a:solidFill>
+                  <a:srgbClr val="56687A"/>
+                </a:solidFill>
+              </a:defRPr>
+            </a:lvl1pPr>
+          </a:lstStyle>
+          <a:p>
+            <a:pPr algn="r"/>
+            <a:fld id="{F7021451-1387-4CA6-816F-3879F97B5CBC}" type="slidenum">
+              <a:rPr b="0" lang="en-US"/>
+              <a:t>10</a:t>
+            </a:fld>
+            <a:endParaRPr lang="en-US"/>
           </a:p>
         </p:txBody>
       </p:sp>
@@ -2152,7 +2908,7 @@
       </p:grpSpPr>
       <p:sp>
         <p:nvSpPr>
-          <p:cNvPr id="2" name="titel-264"/>
+          <p:cNvPr id="2" name="titel-362"/>
           <p:cNvSpPr txBox="1"/>
           <p:nvPr/>
         </p:nvSpPr>
@@ -2180,7 +2936,7 @@
                   <a:srgbClr val="14232F"/>
                 </a:solidFill>
               </a:rPr>
-              <a:t>Ablauf</a:t>
+              <a:t>Ablauf heute</a:t>
             </a:r>
             <a:endParaRPr lang="en-US" sz="2800" dirty="0"/>
           </a:p>
@@ -2188,14 +2944,114 @@
       </p:sp>
       <p:sp>
         <p:nvSpPr>
-          <p:cNvPr id="3" name="tile-265"/>
+          <p:cNvPr id="3" name="phase-363"/>
           <p:cNvSpPr txBox="1"/>
           <p:nvPr/>
         </p:nvSpPr>
         <p:spPr>
           <a:xfrm>
-            <a:off x="548640" y="1600200"/>
-            <a:ext cx="5440680" cy="2194560"/>
+            <a:off x="548640" y="1783080"/>
+            <a:ext cx="5341468" cy="2651760"/>
+          </a:xfrm>
+          <a:prstGeom prst="rect">
+            <a:avLst/>
+          </a:prstGeom>
+          <a:solidFill>
+            <a:srgbClr val="FBE3EC"/>
+          </a:solidFill>
+          <a:ln w="31750">
+            <a:solidFill>
+              <a:srgbClr val="C2255C"/>
+            </a:solidFill>
+          </a:ln>
+        </p:spPr>
+        <p:txBody>
+          <a:bodyPr wrap="square" lIns="152400" tIns="152400" rIns="152400" bIns="152400" rtlCol="0" anchor="t"/>
+          <a:lstStyle/>
+          <a:p>
+            <a:pPr indent="0" marL="0">
+              <a:buNone/>
+            </a:pPr>
+            <a:r>
+              <a:rPr lang="en-US" sz="2200" b="1" dirty="0">
+                <a:solidFill>
+                  <a:srgbClr val="C2255C"/>
+                </a:solidFill>
+              </a:rPr>
+              <a:t>Referat und Diskussion</a:t>
+            </a:r>
+            <a:endParaRPr lang="en-US" sz="2200" dirty="0"/>
+          </a:p>
+          <a:p>
+            <a:pPr indent="0" marL="0">
+              <a:spcBef>
+                <a:spcPts val="600"/>
+              </a:spcBef>
+              <a:buNone/>
+            </a:pPr>
+            <a:r>
+              <a:rPr lang="en-US" sz="2000" dirty="0">
+                <a:solidFill>
+                  <a:srgbClr val="14232F"/>
+                </a:solidFill>
+              </a:rPr>
+              <a:t>Dein Referat oder Vortrag und die Diskussion</a:t>
+            </a:r>
+            <a:endParaRPr lang="en-US" sz="2200" dirty="0"/>
+          </a:p>
+          <a:p>
+            <a:pPr indent="0" marL="0">
+              <a:spcBef>
+                <a:spcPts val="1000"/>
+              </a:spcBef>
+              <a:buNone/>
+            </a:pPr>
+            <a:r>
+              <a:rPr lang="en-US" sz="1800" b="1" dirty="0">
+                <a:solidFill>
+                  <a:srgbClr val="14232F"/>
+                </a:solidFill>
+              </a:rPr>
+              <a:t>Folien 3–8</a:t>
+            </a:r>
+            <a:endParaRPr lang="en-US" sz="2200" dirty="0"/>
+          </a:p>
+        </p:txBody>
+      </p:sp>
+      <p:sp>
+        <p:nvSpPr>
+          <p:cNvPr id="4" name="arrow-364"/>
+          <p:cNvSpPr/>
+          <p:nvPr/>
+        </p:nvSpPr>
+        <p:spPr>
+          <a:xfrm>
+            <a:off x="5944972" y="3108960"/>
+            <a:ext cx="301752" cy="914"/>
+          </a:xfrm>
+          <a:prstGeom prst="line">
+            <a:avLst/>
+          </a:prstGeom>
+          <a:noFill/>
+          <a:ln w="25400">
+            <a:solidFill>
+              <a:srgbClr val="56687A"/>
+            </a:solidFill>
+            <a:prstDash val="solid"/>
+            <a:tailEnd type="triangle"/>
+          </a:ln>
+        </p:spPr>
+      </p:sp>
+      <p:sp>
+        <p:nvSpPr>
+          <p:cNvPr id="5" name="phase-365"/>
+          <p:cNvSpPr txBox="1"/>
+          <p:nvPr/>
+        </p:nvSpPr>
+        <p:spPr>
+          <a:xfrm>
+            <a:off x="6301588" y="1783080"/>
+            <a:ext cx="5341468" cy="2651760"/>
           </a:xfrm>
           <a:prstGeom prst="rect">
             <a:avLst/>
@@ -2203,180 +3059,98 @@
           <a:solidFill>
             <a:srgbClr val="FFF3C9"/>
           </a:solidFill>
-          <a:ln w="6350">
+          <a:ln w="31750">
             <a:solidFill>
-              <a:srgbClr val="FFF3C9"/>
+              <a:srgbClr val="F5B700"/>
             </a:solidFill>
           </a:ln>
         </p:spPr>
         <p:txBody>
-          <a:bodyPr wrap="square" lIns="127000" tIns="127000" rIns="127000" bIns="127000" rtlCol="0" anchor="t"/>
+          <a:bodyPr wrap="square" lIns="152400" tIns="152400" rIns="152400" bIns="152400" rtlCol="0" anchor="t"/>
           <a:lstStyle/>
           <a:p>
             <a:pPr indent="0" marL="0">
               <a:buNone/>
             </a:pPr>
             <a:r>
-              <a:rPr lang="en-US" sz="2600" b="1" dirty="0">
-                <a:solidFill>
-                  <a:srgbClr val="035591"/>
-                </a:solidFill>
-              </a:rPr>
-              <a:t>Weg A · Referat</a:t>
-            </a:r>
-            <a:endParaRPr lang="en-US" sz="2600" dirty="0"/>
-          </a:p>
-          <a:p>
-            <a:pPr marL="203200" indent="-203200">
+              <a:rPr lang="en-US" sz="2200" b="1" dirty="0">
+                <a:solidFill>
+                  <a:srgbClr val="B7791F"/>
+                </a:solidFill>
+              </a:rPr>
+              <a:t>Aufgaben für zu Hause</a:t>
+            </a:r>
+            <a:endParaRPr lang="en-US" sz="2200" dirty="0"/>
+          </a:p>
+          <a:p>
+            <a:pPr indent="0" marL="0">
               <a:spcBef>
-                <a:spcPts val="400"/>
+                <a:spcPts val="600"/>
               </a:spcBef>
-              <a:buSzPct val="100000"/>
-              <a:buChar char="•"/>
-            </a:pPr>
-            <a:r>
-              <a:rPr lang="en-US" sz="2200" dirty="0">
+              <a:buNone/>
+            </a:pPr>
+            <a:r>
+              <a:rPr lang="en-US" sz="2000" dirty="0">
                 <a:solidFill>
                   <a:srgbClr val="14232F"/>
                 </a:solidFill>
               </a:rPr>
-              <a:t>20 Min. + Diskussion</a:t>
-            </a:r>
-            <a:endParaRPr lang="en-US" sz="2600" dirty="0"/>
-          </a:p>
-          <a:p>
-            <a:pPr marL="203200" indent="-203200">
+              <a:t>Aufgabenpaket 4: Diskussionsergebnisse und Ausarbeitung</a:t>
+            </a:r>
+            <a:endParaRPr lang="en-US" sz="2200" dirty="0"/>
+          </a:p>
+          <a:p>
+            <a:pPr indent="0" marL="0">
               <a:spcBef>
-                <a:spcPts val="400"/>
+                <a:spcPts val="1000"/>
               </a:spcBef>
-              <a:buSzPct val="100000"/>
-              <a:buChar char="•"/>
-            </a:pPr>
-            <a:r>
-              <a:rPr lang="en-US" sz="2200" dirty="0">
+              <a:buNone/>
+            </a:pPr>
+            <a:r>
+              <a:rPr lang="en-US" sz="1800" b="1" dirty="0">
                 <a:solidFill>
                   <a:srgbClr val="14232F"/>
                 </a:solidFill>
               </a:rPr>
-              <a:t>danach Ausarbeitung (über 10 Seiten)</a:t>
-            </a:r>
-            <a:endParaRPr lang="en-US" sz="2600" dirty="0"/>
-          </a:p>
-        </p:txBody>
-      </p:sp>
-      <p:sp>
-        <p:nvSpPr>
-          <p:cNvPr id="4" name="tile-266"/>
+              <a:t>Folien 9–10</a:t>
+            </a:r>
+            <a:endParaRPr lang="en-US" sz="2200" dirty="0"/>
+          </a:p>
+        </p:txBody>
+      </p:sp>
+      <p:sp>
+        <p:nvSpPr>
+          <p:cNvPr id="6" name="text-366"/>
           <p:cNvSpPr txBox="1"/>
           <p:nvPr/>
         </p:nvSpPr>
         <p:spPr>
           <a:xfrm>
-            <a:off x="6199632" y="1600200"/>
-            <a:ext cx="5440680" cy="2194560"/>
-          </a:xfrm>
-          <a:prstGeom prst="rect">
-            <a:avLst/>
-          </a:prstGeom>
-          <a:solidFill>
-            <a:srgbClr val="E2F4E8"/>
-          </a:solidFill>
-          <a:ln w="6350">
-            <a:solidFill>
-              <a:srgbClr val="E2F4E8"/>
-            </a:solidFill>
-          </a:ln>
-        </p:spPr>
-        <p:txBody>
-          <a:bodyPr wrap="square" lIns="127000" tIns="127000" rIns="127000" bIns="127000" rtlCol="0" anchor="t"/>
-          <a:lstStyle/>
-          <a:p>
-            <a:pPr indent="0" marL="0">
+            <a:off x="548640" y="4754880"/>
+            <a:ext cx="11094415" cy="914400"/>
+          </a:xfrm>
+          <a:prstGeom prst="rect">
+            <a:avLst/>
+          </a:prstGeom>
+          <a:noFill/>
+          <a:ln/>
+        </p:spPr>
+        <p:txBody>
+          <a:bodyPr wrap="square" lIns="38100" tIns="38100" rIns="38100" bIns="38100" rtlCol="0" anchor="t"/>
+          <a:lstStyle/>
+          <a:p>
+            <a:pPr algn="l" indent="0" marL="0">
               <a:buNone/>
             </a:pPr>
             <a:r>
-              <a:rPr lang="en-US" sz="2600" b="1" dirty="0">
-                <a:solidFill>
-                  <a:srgbClr val="035591"/>
-                </a:solidFill>
-              </a:rPr>
-              <a:t>Weg B · Vortrag</a:t>
-            </a:r>
-            <a:endParaRPr lang="en-US" sz="2600" dirty="0"/>
-          </a:p>
-          <a:p>
-            <a:pPr marL="203200" indent="-203200">
-              <a:spcBef>
-                <a:spcPts val="400"/>
-              </a:spcBef>
-              <a:buSzPct val="100000"/>
-              <a:buChar char="•"/>
-            </a:pPr>
-            <a:r>
-              <a:rPr lang="en-US" sz="2200" dirty="0">
-                <a:solidFill>
-                  <a:srgbClr val="14232F"/>
-                </a:solidFill>
-              </a:rPr>
-              <a:t>40 Min. + Diskussion</a:t>
-            </a:r>
-            <a:endParaRPr lang="en-US" sz="2600" dirty="0"/>
-          </a:p>
-          <a:p>
-            <a:pPr marL="203200" indent="-203200">
-              <a:spcBef>
-                <a:spcPts val="400"/>
-              </a:spcBef>
-              <a:buSzPct val="100000"/>
-              <a:buChar char="•"/>
-            </a:pPr>
-            <a:r>
-              <a:rPr lang="en-US" sz="2200" dirty="0">
-                <a:solidFill>
-                  <a:srgbClr val="14232F"/>
-                </a:solidFill>
-              </a:rPr>
-              <a:t>keine Ausarbeitung</a:t>
-            </a:r>
-            <a:endParaRPr lang="en-US" sz="2600" dirty="0"/>
-          </a:p>
-        </p:txBody>
-      </p:sp>
-      <p:sp>
-        <p:nvSpPr>
-          <p:cNvPr id="5" name="box-267"/>
-          <p:cNvSpPr txBox="1"/>
-          <p:nvPr/>
-        </p:nvSpPr>
-        <p:spPr>
-          <a:xfrm>
-            <a:off x="548640" y="4206240"/>
-            <a:ext cx="11094415" cy="822960"/>
-          </a:xfrm>
-          <a:prstGeom prst="rect">
-            <a:avLst/>
-          </a:prstGeom>
-          <a:solidFill>
-            <a:srgbClr val="FFFFFF"/>
-          </a:solidFill>
-          <a:ln/>
-        </p:spPr>
-        <p:txBody>
-          <a:bodyPr wrap="square" lIns="101600" tIns="101600" rIns="101600" bIns="101600" rtlCol="0" anchor="ctr"/>
-          <a:lstStyle/>
-          <a:p>
-            <a:pPr algn="ctr" indent="0" marL="0">
-              <a:buNone/>
-            </a:pPr>
-            <a:r>
-              <a:rPr lang="en-US" sz="2400" b="1" dirty="0">
-                <a:solidFill>
-                  <a:srgbClr val="035591"/>
-                </a:solidFill>
-              </a:rPr>
-              <a:t>Die Präsentation liegt als PDF vor.</a:t>
-            </a:r>
-            <a:endParaRPr lang="en-US" sz="2400" dirty="0"/>
+              <a:rPr lang="en-US" sz="2000" dirty="0">
+                <a:solidFill>
+                  <a:srgbClr val="56687A"/>
+                </a:solidFill>
+              </a:rPr>
+              <a:t>Nach dem Termin: Diskussionsergebnisse festhalten und – bei Weg A – die Ausarbeitung schreiben.</a:t>
+            </a:r>
+            <a:endParaRPr lang="en-US" sz="2000" dirty="0"/>
           </a:p>
         </p:txBody>
       </p:sp>
@@ -2436,6 +3210,13 @@
 <file path=ppt/slides/slide3.xml><?xml version="1.0" encoding="utf-8"?>
 <p:sld xmlns:a="http://schemas.openxmlformats.org/drawingml/2006/main" xmlns:r="http://schemas.openxmlformats.org/officeDocument/2006/relationships" xmlns:p="http://schemas.openxmlformats.org/presentationml/2006/main">
   <p:cSld name="Slide 3">
+    <p:bg>
+      <p:bgPr>
+        <a:solidFill>
+          <a:srgbClr val="FBE3EC"/>
+        </a:solidFill>
+      </p:bgPr>
+    </p:bg>
     <p:spTree>
       <p:nvGrpSpPr>
         <p:cNvPr id="1" name=""/>
@@ -2452,14 +3233,72 @@
       </p:grpSpPr>
       <p:sp>
         <p:nvSpPr>
-          <p:cNvPr id="2" name="titel-268"/>
+          <p:cNvPr id="2" name="band-367"/>
+          <p:cNvSpPr/>
+          <p:nvPr/>
+        </p:nvSpPr>
+        <p:spPr>
+          <a:xfrm>
+            <a:off x="0" y="0"/>
+            <a:ext cx="320040" cy="6858000"/>
+          </a:xfrm>
+          <a:prstGeom prst="rect">
+            <a:avLst/>
+          </a:prstGeom>
+          <a:solidFill>
+            <a:srgbClr val="C2255C"/>
+          </a:solidFill>
+          <a:ln/>
+        </p:spPr>
+      </p:sp>
+      <p:sp>
+        <p:nvSpPr>
+          <p:cNvPr id="3" name="box-368"/>
           <p:cNvSpPr txBox="1"/>
           <p:nvPr/>
         </p:nvSpPr>
         <p:spPr>
           <a:xfrm>
-            <a:off x="548640" y="896112"/>
-            <a:ext cx="11094415" cy="640080"/>
+            <a:off x="822960" y="1463040"/>
+            <a:ext cx="5852160" cy="640080"/>
+          </a:xfrm>
+          <a:prstGeom prst="rect">
+            <a:avLst/>
+          </a:prstGeom>
+          <a:solidFill>
+            <a:srgbClr val="C2255C"/>
+          </a:solidFill>
+          <a:ln/>
+        </p:spPr>
+        <p:txBody>
+          <a:bodyPr wrap="square" lIns="101600" tIns="101600" rIns="101600" bIns="101600" rtlCol="0" anchor="ctr"/>
+          <a:lstStyle/>
+          <a:p>
+            <a:pPr algn="ctr" indent="0" marL="0">
+              <a:buNone/>
+            </a:pPr>
+            <a:r>
+              <a:rPr lang="en-US" sz="2400" b="1" dirty="0">
+                <a:solidFill>
+                  <a:srgbClr val="FFFFFF"/>
+                </a:solidFill>
+              </a:rPr>
+              <a:t>REFERAT UND DISKUSSION</a:t>
+            </a:r>
+            <a:endParaRPr lang="en-US" sz="2400" dirty="0"/>
+          </a:p>
+        </p:txBody>
+      </p:sp>
+      <p:sp>
+        <p:nvSpPr>
+          <p:cNvPr id="4" name="titel-369"/>
+          <p:cNvSpPr txBox="1"/>
+          <p:nvPr/>
+        </p:nvSpPr>
+        <p:spPr>
+          <a:xfrm>
+            <a:off x="822960" y="2377440"/>
+            <a:ext cx="10607040" cy="1828800"/>
           </a:xfrm>
           <a:prstGeom prst="rect">
             <a:avLst/>
@@ -2468,34 +3307,34 @@
           <a:ln/>
         </p:spPr>
         <p:txBody>
-          <a:bodyPr wrap="square" lIns="0" tIns="0" rIns="0" bIns="0" rtlCol="0" anchor="ctr"/>
+          <a:bodyPr wrap="square" lIns="0" tIns="0" rIns="0" bIns="0" rtlCol="0" anchor="t"/>
           <a:lstStyle/>
           <a:p>
             <a:pPr indent="0" marL="0">
               <a:buNone/>
             </a:pPr>
             <a:r>
-              <a:rPr lang="en-US" sz="2800" b="1" dirty="0">
+              <a:rPr lang="en-US" sz="4000" b="1" dirty="0">
                 <a:solidFill>
                   <a:srgbClr val="14232F"/>
                 </a:solidFill>
               </a:rPr>
-              <a:t>Dein Referat oder Vortrag</a:t>
-            </a:r>
-            <a:endParaRPr lang="en-US" sz="2800" dirty="0"/>
-          </a:p>
-        </p:txBody>
-      </p:sp>
-      <p:sp>
-        <p:nvSpPr>
-          <p:cNvPr id="3" name="text-269"/>
+              <a:t>Dein Referat oder Vortrag und die Diskussion</a:t>
+            </a:r>
+            <a:endParaRPr lang="en-US" sz="4000" dirty="0"/>
+          </a:p>
+        </p:txBody>
+      </p:sp>
+      <p:sp>
+        <p:nvSpPr>
+          <p:cNvPr id="5" name="text-370"/>
           <p:cNvSpPr txBox="1"/>
           <p:nvPr/>
         </p:nvSpPr>
         <p:spPr>
           <a:xfrm>
-            <a:off x="548640" y="1691640"/>
-            <a:ext cx="11094415" cy="1097280"/>
+            <a:off x="822960" y="4480560"/>
+            <a:ext cx="10607040" cy="731520"/>
           </a:xfrm>
           <a:prstGeom prst="rect">
             <a:avLst/>
@@ -2504,457 +3343,21 @@
           <a:ln/>
         </p:spPr>
         <p:txBody>
-          <a:bodyPr wrap="square" lIns="38100" tIns="38100" rIns="38100" bIns="38100" rtlCol="0" anchor="ctr"/>
-          <a:lstStyle/>
-          <a:p>
-            <a:pPr algn="ctr" indent="0" marL="0">
+          <a:bodyPr wrap="square" lIns="38100" tIns="38100" rIns="38100" bIns="38100" rtlCol="0" anchor="t"/>
+          <a:lstStyle/>
+          <a:p>
+            <a:pPr algn="l" indent="0" marL="0">
               <a:buNone/>
             </a:pPr>
             <a:r>
-              <a:rPr lang="en-US" sz="5400" b="1" dirty="0">
-                <a:solidFill>
-                  <a:srgbClr val="035591"/>
-                </a:solidFill>
-              </a:rPr>
-              <a:t>Bühne frei</a:t>
-            </a:r>
-            <a:endParaRPr lang="en-US" sz="5400" dirty="0"/>
-          </a:p>
-        </p:txBody>
-      </p:sp>
-      <p:sp>
-        <p:nvSpPr>
-          <p:cNvPr id="4" name="step-270"/>
-          <p:cNvSpPr txBox="1"/>
-          <p:nvPr/>
-        </p:nvSpPr>
-        <p:spPr>
-          <a:xfrm>
-            <a:off x="548640" y="3200400"/>
-            <a:ext cx="1889699" cy="1737360"/>
-          </a:xfrm>
-          <a:prstGeom prst="rect">
-            <a:avLst/>
-          </a:prstGeom>
-          <a:solidFill>
-            <a:srgbClr val="FFFFFF"/>
-          </a:solidFill>
-          <a:ln w="25400">
-            <a:solidFill>
-              <a:srgbClr val="035591"/>
-            </a:solidFill>
-          </a:ln>
-        </p:spPr>
-        <p:txBody>
-          <a:bodyPr wrap="square" lIns="114300" tIns="114300" rIns="114300" bIns="114300" rtlCol="0" anchor="t"/>
-          <a:lstStyle/>
-          <a:p>
-            <a:pPr indent="0" marL="0">
-              <a:buNone/>
-            </a:pPr>
-            <a:r>
-              <a:rPr lang="en-US" sz="2000" b="1" dirty="0">
-                <a:solidFill>
-                  <a:srgbClr val="035591"/>
-                </a:solidFill>
-              </a:rPr>
-              <a:t>Einleitung</a:t>
-            </a:r>
-            <a:endParaRPr lang="en-US" sz="2000" dirty="0"/>
-          </a:p>
-          <a:p>
-            <a:pPr indent="0" marL="0">
-              <a:spcBef>
-                <a:spcPts val="400"/>
-              </a:spcBef>
-              <a:buNone/>
-            </a:pPr>
-            <a:r>
-              <a:rPr lang="en-US" sz="1600" dirty="0">
-                <a:solidFill>
-                  <a:srgbClr val="14232F"/>
-                </a:solidFill>
-              </a:rPr>
-              <a:t>Fragestellung</a:t>
-            </a:r>
-            <a:endParaRPr lang="en-US" sz="2000" dirty="0"/>
-          </a:p>
-        </p:txBody>
-      </p:sp>
-      <p:sp>
-        <p:nvSpPr>
-          <p:cNvPr id="5" name="arrow-271"/>
-          <p:cNvSpPr/>
-          <p:nvPr/>
-        </p:nvSpPr>
-        <p:spPr>
-          <a:xfrm>
-            <a:off x="2493203" y="4069080"/>
-            <a:ext cx="301752" cy="914"/>
-          </a:xfrm>
-          <a:prstGeom prst="line">
-            <a:avLst/>
-          </a:prstGeom>
-          <a:noFill/>
-          <a:ln w="25400">
-            <a:solidFill>
-              <a:srgbClr val="035591"/>
-            </a:solidFill>
-            <a:prstDash val="solid"/>
-            <a:tailEnd type="triangle"/>
-          </a:ln>
-        </p:spPr>
-      </p:sp>
-      <p:sp>
-        <p:nvSpPr>
-          <p:cNvPr id="6" name="step-272"/>
-          <p:cNvSpPr txBox="1"/>
-          <p:nvPr/>
-        </p:nvSpPr>
-        <p:spPr>
-          <a:xfrm>
-            <a:off x="2849819" y="3200400"/>
-            <a:ext cx="1889699" cy="1737360"/>
-          </a:xfrm>
-          <a:prstGeom prst="rect">
-            <a:avLst/>
-          </a:prstGeom>
-          <a:solidFill>
-            <a:srgbClr val="FFFFFF"/>
-          </a:solidFill>
-          <a:ln w="25400">
-            <a:solidFill>
-              <a:srgbClr val="035591"/>
-            </a:solidFill>
-          </a:ln>
-        </p:spPr>
-        <p:txBody>
-          <a:bodyPr wrap="square" lIns="114300" tIns="114300" rIns="114300" bIns="114300" rtlCol="0" anchor="t"/>
-          <a:lstStyle/>
-          <a:p>
-            <a:pPr indent="0" marL="0">
-              <a:buNone/>
-            </a:pPr>
-            <a:r>
-              <a:rPr lang="en-US" sz="2000" b="1" dirty="0">
-                <a:solidFill>
-                  <a:srgbClr val="035591"/>
-                </a:solidFill>
-              </a:rPr>
-              <a:t>Klärung</a:t>
-            </a:r>
-            <a:endParaRPr lang="en-US" sz="2000" dirty="0"/>
-          </a:p>
-          <a:p>
-            <a:pPr indent="0" marL="0">
-              <a:spcBef>
-                <a:spcPts val="400"/>
-              </a:spcBef>
-              <a:buNone/>
-            </a:pPr>
-            <a:r>
-              <a:rPr lang="en-US" sz="1600" dirty="0">
-                <a:solidFill>
-                  <a:srgbClr val="14232F"/>
-                </a:solidFill>
-              </a:rPr>
-              <a:t>Begriffe, Positionen</a:t>
-            </a:r>
-            <a:endParaRPr lang="en-US" sz="2000" dirty="0"/>
-          </a:p>
-        </p:txBody>
-      </p:sp>
-      <p:sp>
-        <p:nvSpPr>
-          <p:cNvPr id="7" name="arrow-273"/>
-          <p:cNvSpPr/>
-          <p:nvPr/>
-        </p:nvSpPr>
-        <p:spPr>
-          <a:xfrm>
-            <a:off x="4794382" y="4069080"/>
-            <a:ext cx="301752" cy="914"/>
-          </a:xfrm>
-          <a:prstGeom prst="line">
-            <a:avLst/>
-          </a:prstGeom>
-          <a:noFill/>
-          <a:ln w="25400">
-            <a:solidFill>
-              <a:srgbClr val="035591"/>
-            </a:solidFill>
-            <a:prstDash val="solid"/>
-            <a:tailEnd type="triangle"/>
-          </a:ln>
-        </p:spPr>
-      </p:sp>
-      <p:sp>
-        <p:nvSpPr>
-          <p:cNvPr id="8" name="step-274"/>
-          <p:cNvSpPr txBox="1"/>
-          <p:nvPr/>
-        </p:nvSpPr>
-        <p:spPr>
-          <a:xfrm>
-            <a:off x="5150998" y="3200400"/>
-            <a:ext cx="1889699" cy="1737360"/>
-          </a:xfrm>
-          <a:prstGeom prst="rect">
-            <a:avLst/>
-          </a:prstGeom>
-          <a:solidFill>
-            <a:srgbClr val="FFFFFF"/>
-          </a:solidFill>
-          <a:ln w="25400">
-            <a:solidFill>
-              <a:srgbClr val="035591"/>
-            </a:solidFill>
-          </a:ln>
-        </p:spPr>
-        <p:txBody>
-          <a:bodyPr wrap="square" lIns="114300" tIns="114300" rIns="114300" bIns="114300" rtlCol="0" anchor="t"/>
-          <a:lstStyle/>
-          <a:p>
-            <a:pPr indent="0" marL="0">
-              <a:buNone/>
-            </a:pPr>
-            <a:r>
-              <a:rPr lang="en-US" sz="2000" b="1" dirty="0">
-                <a:solidFill>
-                  <a:srgbClr val="035591"/>
-                </a:solidFill>
-              </a:rPr>
-              <a:t>Hauptteil</a:t>
-            </a:r>
-            <a:endParaRPr lang="en-US" sz="2000" dirty="0"/>
-          </a:p>
-          <a:p>
-            <a:pPr indent="0" marL="0">
-              <a:spcBef>
-                <a:spcPts val="400"/>
-              </a:spcBef>
-              <a:buNone/>
-            </a:pPr>
-            <a:r>
-              <a:rPr lang="en-US" sz="1600" dirty="0">
-                <a:solidFill>
-                  <a:srgbClr val="14232F"/>
-                </a:solidFill>
-              </a:rPr>
-              <a:t>Quellen, Praxis, Kritik</a:t>
-            </a:r>
-            <a:endParaRPr lang="en-US" sz="2000" dirty="0"/>
-          </a:p>
-        </p:txBody>
-      </p:sp>
-      <p:sp>
-        <p:nvSpPr>
-          <p:cNvPr id="9" name="arrow-275"/>
-          <p:cNvSpPr/>
-          <p:nvPr/>
-        </p:nvSpPr>
-        <p:spPr>
-          <a:xfrm>
-            <a:off x="7095561" y="4069080"/>
-            <a:ext cx="301752" cy="914"/>
-          </a:xfrm>
-          <a:prstGeom prst="line">
-            <a:avLst/>
-          </a:prstGeom>
-          <a:noFill/>
-          <a:ln w="25400">
-            <a:solidFill>
-              <a:srgbClr val="035591"/>
-            </a:solidFill>
-            <a:prstDash val="solid"/>
-            <a:tailEnd type="triangle"/>
-          </a:ln>
-        </p:spPr>
-      </p:sp>
-      <p:sp>
-        <p:nvSpPr>
-          <p:cNvPr id="10" name="step-276"/>
-          <p:cNvSpPr txBox="1"/>
-          <p:nvPr/>
-        </p:nvSpPr>
-        <p:spPr>
-          <a:xfrm>
-            <a:off x="7452177" y="3200400"/>
-            <a:ext cx="1889699" cy="1737360"/>
-          </a:xfrm>
-          <a:prstGeom prst="rect">
-            <a:avLst/>
-          </a:prstGeom>
-          <a:solidFill>
-            <a:srgbClr val="FFFFFF"/>
-          </a:solidFill>
-          <a:ln w="25400">
-            <a:solidFill>
-              <a:srgbClr val="035591"/>
-            </a:solidFill>
-          </a:ln>
-        </p:spPr>
-        <p:txBody>
-          <a:bodyPr wrap="square" lIns="114300" tIns="114300" rIns="114300" bIns="114300" rtlCol="0" anchor="t"/>
-          <a:lstStyle/>
-          <a:p>
-            <a:pPr indent="0" marL="0">
-              <a:buNone/>
-            </a:pPr>
-            <a:r>
-              <a:rPr lang="en-US" sz="2000" b="1" dirty="0">
-                <a:solidFill>
-                  <a:srgbClr val="035591"/>
-                </a:solidFill>
-              </a:rPr>
-              <a:t>Fazit</a:t>
-            </a:r>
-            <a:endParaRPr lang="en-US" sz="2000" dirty="0"/>
-          </a:p>
-          <a:p>
-            <a:pPr indent="0" marL="0">
-              <a:spcBef>
-                <a:spcPts val="400"/>
-              </a:spcBef>
-              <a:buNone/>
-            </a:pPr>
-            <a:r>
-              <a:rPr lang="en-US" sz="1600" dirty="0">
-                <a:solidFill>
-                  <a:srgbClr val="14232F"/>
-                </a:solidFill>
-              </a:rPr>
-              <a:t>Ansätze für die Diskussion</a:t>
-            </a:r>
-            <a:endParaRPr lang="en-US" sz="2000" dirty="0"/>
-          </a:p>
-        </p:txBody>
-      </p:sp>
-      <p:sp>
-        <p:nvSpPr>
-          <p:cNvPr id="11" name="arrow-277"/>
-          <p:cNvSpPr/>
-          <p:nvPr/>
-        </p:nvSpPr>
-        <p:spPr>
-          <a:xfrm>
-            <a:off x="9396740" y="4069080"/>
-            <a:ext cx="301752" cy="914"/>
-          </a:xfrm>
-          <a:prstGeom prst="line">
-            <a:avLst/>
-          </a:prstGeom>
-          <a:noFill/>
-          <a:ln w="25400">
-            <a:solidFill>
-              <a:srgbClr val="035591"/>
-            </a:solidFill>
-            <a:prstDash val="solid"/>
-            <a:tailEnd type="triangle"/>
-          </a:ln>
-        </p:spPr>
-      </p:sp>
-      <p:sp>
-        <p:nvSpPr>
-          <p:cNvPr id="12" name="step-278"/>
-          <p:cNvSpPr txBox="1"/>
-          <p:nvPr/>
-        </p:nvSpPr>
-        <p:spPr>
-          <a:xfrm>
-            <a:off x="9753356" y="3200400"/>
-            <a:ext cx="1889699" cy="1737360"/>
-          </a:xfrm>
-          <a:prstGeom prst="rect">
-            <a:avLst/>
-          </a:prstGeom>
-          <a:solidFill>
-            <a:srgbClr val="FFFFFF"/>
-          </a:solidFill>
-          <a:ln w="25400">
-            <a:solidFill>
-              <a:srgbClr val="035591"/>
-            </a:solidFill>
-          </a:ln>
-        </p:spPr>
-        <p:txBody>
-          <a:bodyPr wrap="square" lIns="114300" tIns="114300" rIns="114300" bIns="114300" rtlCol="0" anchor="t"/>
-          <a:lstStyle/>
-          <a:p>
-            <a:pPr indent="0" marL="0">
-              <a:buNone/>
-            </a:pPr>
-            <a:r>
-              <a:rPr lang="en-US" sz="2000" b="1" dirty="0">
-                <a:solidFill>
-                  <a:srgbClr val="035591"/>
-                </a:solidFill>
-              </a:rPr>
-              <a:t>Diskussion</a:t>
-            </a:r>
-            <a:endParaRPr lang="en-US" sz="2000" dirty="0"/>
-          </a:p>
-          <a:p>
-            <a:pPr indent="0" marL="0">
-              <a:spcBef>
-                <a:spcPts val="400"/>
-              </a:spcBef>
-              <a:buNone/>
-            </a:pPr>
-            <a:r>
-              <a:rPr lang="en-US" sz="1600" dirty="0">
-                <a:solidFill>
-                  <a:srgbClr val="14232F"/>
-                </a:solidFill>
-              </a:rPr>
-              <a:t>Fragen mit Impulsen</a:t>
-            </a:r>
-            <a:endParaRPr lang="en-US" sz="2000" dirty="0"/>
-          </a:p>
-        </p:txBody>
-      </p:sp>
-      <p:sp>
-        <p:nvSpPr>
-          <p:cNvPr id="25" name="Slide Number Placeholder 0"/>
-          <p:cNvSpPr>
-            <a:spLocks noGrp="1"/>
-          </p:cNvSpPr>
-          <p:nvPr>
-            <p:ph type="sldNum" sz="quarter" idx="4294967295"/>
-          </p:nvPr>
-        </p:nvSpPr>
-        <p:spPr>
-          <a:xfrm>
-            <a:off x="11247120" y="6473952"/>
-            <a:ext cx="548640" cy="274320"/>
-          </a:xfrm>
-          <a:prstGeom prst="rect">
-            <a:avLst/>
-          </a:prstGeom>
-          <a:extLst>
-            <a:ext uri="{C572A759-6A51-4108-AA02-DFA0A04FC94B}">
-              <ma14:wrappingTextBoxFlag xmlns:ma14="http://schemas.microsoft.com/office/mac/drawingml/2011/main" val="0"/>
-            </a:ext>
-          </a:extLst>
-        </p:spPr>
-        <p:txBody>
-          <a:bodyPr/>
-          <a:lstStyle>
-            <a:lvl1pPr>
-              <a:defRPr sz="1000">
+              <a:rPr lang="en-US" sz="2600" dirty="0">
                 <a:solidFill>
                   <a:srgbClr val="56687A"/>
                 </a:solidFill>
-              </a:defRPr>
-            </a:lvl1pPr>
-          </a:lstStyle>
-          <a:p>
-            <a:pPr algn="r"/>
-            <a:fld id="{F7021451-1387-4CA6-816F-3879F97B5CBC}" type="slidenum">
-              <a:rPr b="0" lang="en-US"/>
-              <a:t>3</a:t>
-            </a:fld>
-            <a:endParaRPr lang="en-US"/>
+              </a:rPr>
+              <a:t>Im Termin</a:t>
+            </a:r>
+            <a:endParaRPr lang="en-US" sz="2600" dirty="0"/>
           </a:p>
         </p:txBody>
       </p:sp>
@@ -2985,12 +3388,50 @@
       </p:grpSpPr>
       <p:sp>
         <p:nvSpPr>
-          <p:cNvPr id="2" name="titel-279"/>
+          <p:cNvPr id="2" name="box-371"/>
           <p:cNvSpPr txBox="1"/>
           <p:nvPr/>
         </p:nvSpPr>
         <p:spPr>
           <a:xfrm>
+            <a:off x="8915400" y="246888"/>
+            <a:ext cx="2862072" cy="384048"/>
+          </a:xfrm>
+          <a:prstGeom prst="rect">
+            <a:avLst/>
+          </a:prstGeom>
+          <a:solidFill>
+            <a:srgbClr val="C2255C"/>
+          </a:solidFill>
+          <a:ln/>
+        </p:spPr>
+        <p:txBody>
+          <a:bodyPr wrap="square" lIns="25400" tIns="25400" rIns="25400" bIns="25400" rtlCol="0" anchor="ctr"/>
+          <a:lstStyle/>
+          <a:p>
+            <a:pPr algn="ctr" indent="0" marL="0">
+              <a:buNone/>
+            </a:pPr>
+            <a:r>
+              <a:rPr lang="en-US" sz="1400" b="1" dirty="0">
+                <a:solidFill>
+                  <a:srgbClr val="FFFFFF"/>
+                </a:solidFill>
+              </a:rPr>
+              <a:t>Referat und Diskussion</a:t>
+            </a:r>
+            <a:endParaRPr lang="en-US" sz="1400" dirty="0"/>
+          </a:p>
+        </p:txBody>
+      </p:sp>
+      <p:sp>
+        <p:nvSpPr>
+          <p:cNvPr id="3" name="titel-372"/>
+          <p:cNvSpPr txBox="1"/>
+          <p:nvPr/>
+        </p:nvSpPr>
+        <p:spPr>
+          <a:xfrm>
             <a:off x="548640" y="896112"/>
             <a:ext cx="11094415" cy="640080"/>
           </a:xfrm>
@@ -3013,7 +3454,7 @@
                   <a:srgbClr val="14232F"/>
                 </a:solidFill>
               </a:rPr>
-              <a:t>Diskussion</a:t>
+              <a:t>Zwei Wege</a:t>
             </a:r>
             <a:endParaRPr lang="en-US" sz="2800" dirty="0"/>
           </a:p>
@@ -3021,20 +3462,176 @@
       </p:sp>
       <p:sp>
         <p:nvSpPr>
-          <p:cNvPr id="3" name="box-280"/>
+          <p:cNvPr id="4" name="tile-373"/>
           <p:cNvSpPr txBox="1"/>
           <p:nvPr/>
         </p:nvSpPr>
         <p:spPr>
           <a:xfrm>
-            <a:off x="548640" y="1691640"/>
-            <a:ext cx="822960" cy="1097280"/>
+            <a:off x="548640" y="1600200"/>
+            <a:ext cx="5440680" cy="2194560"/>
           </a:xfrm>
           <a:prstGeom prst="rect">
             <a:avLst/>
           </a:prstGeom>
           <a:solidFill>
-            <a:srgbClr val="035591"/>
+            <a:srgbClr val="FFF3C9"/>
+          </a:solidFill>
+          <a:ln w="6350">
+            <a:solidFill>
+              <a:srgbClr val="FFF3C9"/>
+            </a:solidFill>
+          </a:ln>
+        </p:spPr>
+        <p:txBody>
+          <a:bodyPr wrap="square" lIns="127000" tIns="127000" rIns="127000" bIns="127000" rtlCol="0" anchor="t"/>
+          <a:lstStyle/>
+          <a:p>
+            <a:pPr indent="0" marL="0">
+              <a:buNone/>
+            </a:pPr>
+            <a:r>
+              <a:rPr lang="en-US" sz="2600" b="1" dirty="0">
+                <a:solidFill>
+                  <a:srgbClr val="035591"/>
+                </a:solidFill>
+              </a:rPr>
+              <a:t>Weg A · Referat</a:t>
+            </a:r>
+            <a:endParaRPr lang="en-US" sz="2600" dirty="0"/>
+          </a:p>
+          <a:p>
+            <a:pPr marL="203200" indent="-203200">
+              <a:spcBef>
+                <a:spcPts val="400"/>
+              </a:spcBef>
+              <a:buSzPct val="100000"/>
+              <a:buChar char="•"/>
+            </a:pPr>
+            <a:r>
+              <a:rPr lang="en-US" sz="2200" dirty="0">
+                <a:solidFill>
+                  <a:srgbClr val="14232F"/>
+                </a:solidFill>
+              </a:rPr>
+              <a:t>20 Min. + Diskussion</a:t>
+            </a:r>
+            <a:endParaRPr lang="en-US" sz="2600" dirty="0"/>
+          </a:p>
+          <a:p>
+            <a:pPr marL="203200" indent="-203200">
+              <a:spcBef>
+                <a:spcPts val="400"/>
+              </a:spcBef>
+              <a:buSzPct val="100000"/>
+              <a:buChar char="•"/>
+            </a:pPr>
+            <a:r>
+              <a:rPr lang="en-US" sz="2200" dirty="0">
+                <a:solidFill>
+                  <a:srgbClr val="14232F"/>
+                </a:solidFill>
+              </a:rPr>
+              <a:t>danach Ausarbeitung (über 10 Seiten)</a:t>
+            </a:r>
+            <a:endParaRPr lang="en-US" sz="2600" dirty="0"/>
+          </a:p>
+        </p:txBody>
+      </p:sp>
+      <p:sp>
+        <p:nvSpPr>
+          <p:cNvPr id="5" name="tile-374"/>
+          <p:cNvSpPr txBox="1"/>
+          <p:nvPr/>
+        </p:nvSpPr>
+        <p:spPr>
+          <a:xfrm>
+            <a:off x="6199632" y="1600200"/>
+            <a:ext cx="5440680" cy="2194560"/>
+          </a:xfrm>
+          <a:prstGeom prst="rect">
+            <a:avLst/>
+          </a:prstGeom>
+          <a:solidFill>
+            <a:srgbClr val="E2F4E8"/>
+          </a:solidFill>
+          <a:ln w="6350">
+            <a:solidFill>
+              <a:srgbClr val="E2F4E8"/>
+            </a:solidFill>
+          </a:ln>
+        </p:spPr>
+        <p:txBody>
+          <a:bodyPr wrap="square" lIns="127000" tIns="127000" rIns="127000" bIns="127000" rtlCol="0" anchor="t"/>
+          <a:lstStyle/>
+          <a:p>
+            <a:pPr indent="0" marL="0">
+              <a:buNone/>
+            </a:pPr>
+            <a:r>
+              <a:rPr lang="en-US" sz="2600" b="1" dirty="0">
+                <a:solidFill>
+                  <a:srgbClr val="035591"/>
+                </a:solidFill>
+              </a:rPr>
+              <a:t>Weg B · Vortrag</a:t>
+            </a:r>
+            <a:endParaRPr lang="en-US" sz="2600" dirty="0"/>
+          </a:p>
+          <a:p>
+            <a:pPr marL="203200" indent="-203200">
+              <a:spcBef>
+                <a:spcPts val="400"/>
+              </a:spcBef>
+              <a:buSzPct val="100000"/>
+              <a:buChar char="•"/>
+            </a:pPr>
+            <a:r>
+              <a:rPr lang="en-US" sz="2200" dirty="0">
+                <a:solidFill>
+                  <a:srgbClr val="14232F"/>
+                </a:solidFill>
+              </a:rPr>
+              <a:t>40 Min. + Diskussion</a:t>
+            </a:r>
+            <a:endParaRPr lang="en-US" sz="2600" dirty="0"/>
+          </a:p>
+          <a:p>
+            <a:pPr marL="203200" indent="-203200">
+              <a:spcBef>
+                <a:spcPts val="400"/>
+              </a:spcBef>
+              <a:buSzPct val="100000"/>
+              <a:buChar char="•"/>
+            </a:pPr>
+            <a:r>
+              <a:rPr lang="en-US" sz="2200" dirty="0">
+                <a:solidFill>
+                  <a:srgbClr val="14232F"/>
+                </a:solidFill>
+              </a:rPr>
+              <a:t>keine Ausarbeitung</a:t>
+            </a:r>
+            <a:endParaRPr lang="en-US" sz="2600" dirty="0"/>
+          </a:p>
+        </p:txBody>
+      </p:sp>
+      <p:sp>
+        <p:nvSpPr>
+          <p:cNvPr id="6" name="box-375"/>
+          <p:cNvSpPr txBox="1"/>
+          <p:nvPr/>
+        </p:nvSpPr>
+        <p:spPr>
+          <a:xfrm>
+            <a:off x="548640" y="4206240"/>
+            <a:ext cx="11094415" cy="822960"/>
+          </a:xfrm>
+          <a:prstGeom prst="rect">
+            <a:avLst/>
+          </a:prstGeom>
+          <a:solidFill>
+            <a:srgbClr val="FFFFFF"/>
           </a:solidFill>
           <a:ln/>
         </p:spPr>
@@ -3046,202 +3643,12 @@
               <a:buNone/>
             </a:pPr>
             <a:r>
-              <a:rPr lang="en-US" sz="3200" b="1" dirty="0">
-                <a:solidFill>
-                  <a:srgbClr val="FFFFFF"/>
-                </a:solidFill>
-              </a:rPr>
-              <a:t>?</a:t>
-            </a:r>
-            <a:endParaRPr lang="en-US" sz="3200" dirty="0"/>
-          </a:p>
-        </p:txBody>
-      </p:sp>
-      <p:sp>
-        <p:nvSpPr>
-          <p:cNvPr id="4" name="box-281"/>
-          <p:cNvSpPr txBox="1"/>
-          <p:nvPr/>
-        </p:nvSpPr>
-        <p:spPr>
-          <a:xfrm>
-            <a:off x="1508760" y="1691640"/>
-            <a:ext cx="10134295" cy="1097280"/>
-          </a:xfrm>
-          <a:prstGeom prst="rect">
-            <a:avLst/>
-          </a:prstGeom>
-          <a:solidFill>
-            <a:srgbClr val="EEF3F7"/>
-          </a:solidFill>
-          <a:ln/>
-        </p:spPr>
-        <p:txBody>
-          <a:bodyPr wrap="square" lIns="101600" tIns="101600" rIns="101600" bIns="101600" rtlCol="0" anchor="ctr"/>
-          <a:lstStyle/>
-          <a:p>
-            <a:pPr algn="l" indent="0" marL="0">
-              <a:buNone/>
-            </a:pPr>
-            <a:r>
-              <a:rPr lang="en-US" sz="2400" dirty="0">
-                <a:solidFill>
-                  <a:srgbClr val="14232F"/>
-                </a:solidFill>
-              </a:rPr>
-              <a:t>Deine Diskussionsfragen mit Impulsen</a:t>
-            </a:r>
-            <a:endParaRPr lang="en-US" sz="2400" dirty="0"/>
-          </a:p>
-        </p:txBody>
-      </p:sp>
-      <p:sp>
-        <p:nvSpPr>
-          <p:cNvPr id="5" name="box-282"/>
-          <p:cNvSpPr txBox="1"/>
-          <p:nvPr/>
-        </p:nvSpPr>
-        <p:spPr>
-          <a:xfrm>
-            <a:off x="548640" y="3017520"/>
-            <a:ext cx="822960" cy="1097280"/>
-          </a:xfrm>
-          <a:prstGeom prst="rect">
-            <a:avLst/>
-          </a:prstGeom>
-          <a:solidFill>
-            <a:srgbClr val="035591"/>
-          </a:solidFill>
-          <a:ln/>
-        </p:spPr>
-        <p:txBody>
-          <a:bodyPr wrap="square" lIns="101600" tIns="101600" rIns="101600" bIns="101600" rtlCol="0" anchor="ctr"/>
-          <a:lstStyle/>
-          <a:p>
-            <a:pPr algn="ctr" indent="0" marL="0">
-              <a:buNone/>
-            </a:pPr>
-            <a:r>
-              <a:rPr lang="en-US" sz="3200" b="1" dirty="0">
-                <a:solidFill>
-                  <a:srgbClr val="FFFFFF"/>
-                </a:solidFill>
-              </a:rPr>
-              <a:t>?</a:t>
-            </a:r>
-            <a:endParaRPr lang="en-US" sz="3200" dirty="0"/>
-          </a:p>
-        </p:txBody>
-      </p:sp>
-      <p:sp>
-        <p:nvSpPr>
-          <p:cNvPr id="6" name="box-283"/>
-          <p:cNvSpPr txBox="1"/>
-          <p:nvPr/>
-        </p:nvSpPr>
-        <p:spPr>
-          <a:xfrm>
-            <a:off x="1508760" y="3017520"/>
-            <a:ext cx="10134295" cy="1097280"/>
-          </a:xfrm>
-          <a:prstGeom prst="rect">
-            <a:avLst/>
-          </a:prstGeom>
-          <a:solidFill>
-            <a:srgbClr val="EEF3F7"/>
-          </a:solidFill>
-          <a:ln/>
-        </p:spPr>
-        <p:txBody>
-          <a:bodyPr wrap="square" lIns="101600" tIns="101600" rIns="101600" bIns="101600" rtlCol="0" anchor="ctr"/>
-          <a:lstStyle/>
-          <a:p>
-            <a:pPr algn="l" indent="0" marL="0">
-              <a:buNone/>
-            </a:pPr>
-            <a:r>
-              <a:rPr lang="en-US" sz="2400" dirty="0">
-                <a:solidFill>
-                  <a:srgbClr val="14232F"/>
-                </a:solidFill>
-              </a:rPr>
-              <a:t>Wo klaffen Wissenschaft und Schulpraxis auseinander?</a:t>
-            </a:r>
-            <a:endParaRPr lang="en-US" sz="2400" dirty="0"/>
-          </a:p>
-        </p:txBody>
-      </p:sp>
-      <p:sp>
-        <p:nvSpPr>
-          <p:cNvPr id="7" name="box-284"/>
-          <p:cNvSpPr txBox="1"/>
-          <p:nvPr/>
-        </p:nvSpPr>
-        <p:spPr>
-          <a:xfrm>
-            <a:off x="548640" y="4343400"/>
-            <a:ext cx="822960" cy="1097280"/>
-          </a:xfrm>
-          <a:prstGeom prst="rect">
-            <a:avLst/>
-          </a:prstGeom>
-          <a:solidFill>
-            <a:srgbClr val="035591"/>
-          </a:solidFill>
-          <a:ln/>
-        </p:spPr>
-        <p:txBody>
-          <a:bodyPr wrap="square" lIns="101600" tIns="101600" rIns="101600" bIns="101600" rtlCol="0" anchor="ctr"/>
-          <a:lstStyle/>
-          <a:p>
-            <a:pPr algn="ctr" indent="0" marL="0">
-              <a:buNone/>
-            </a:pPr>
-            <a:r>
-              <a:rPr lang="en-US" sz="3200" b="1" dirty="0">
-                <a:solidFill>
-                  <a:srgbClr val="FFFFFF"/>
-                </a:solidFill>
-              </a:rPr>
-              <a:t>?</a:t>
-            </a:r>
-            <a:endParaRPr lang="en-US" sz="3200" dirty="0"/>
-          </a:p>
-        </p:txBody>
-      </p:sp>
-      <p:sp>
-        <p:nvSpPr>
-          <p:cNvPr id="8" name="box-285"/>
-          <p:cNvSpPr txBox="1"/>
-          <p:nvPr/>
-        </p:nvSpPr>
-        <p:spPr>
-          <a:xfrm>
-            <a:off x="1508760" y="4343400"/>
-            <a:ext cx="10134295" cy="1097280"/>
-          </a:xfrm>
-          <a:prstGeom prst="rect">
-            <a:avLst/>
-          </a:prstGeom>
-          <a:solidFill>
-            <a:srgbClr val="EEF3F7"/>
-          </a:solidFill>
-          <a:ln/>
-        </p:spPr>
-        <p:txBody>
-          <a:bodyPr wrap="square" lIns="101600" tIns="101600" rIns="101600" bIns="101600" rtlCol="0" anchor="ctr"/>
-          <a:lstStyle/>
-          <a:p>
-            <a:pPr algn="l" indent="0" marL="0">
-              <a:buNone/>
-            </a:pPr>
-            <a:r>
-              <a:rPr lang="en-US" sz="2400" dirty="0">
-                <a:solidFill>
-                  <a:srgbClr val="14232F"/>
-                </a:solidFill>
-              </a:rPr>
-              <a:t>Was bedeutet das für deinen späteren Technikunterricht?</a:t>
+              <a:rPr lang="en-US" sz="2400" b="1" dirty="0">
+                <a:solidFill>
+                  <a:srgbClr val="035591"/>
+                </a:solidFill>
+              </a:rPr>
+              <a:t>Die Präsentation liegt als PDF vor.</a:t>
             </a:r>
             <a:endParaRPr lang="en-US" sz="2400" dirty="0"/>
           </a:p>
@@ -3319,12 +3726,50 @@
       </p:grpSpPr>
       <p:sp>
         <p:nvSpPr>
-          <p:cNvPr id="2" name="titel-286"/>
+          <p:cNvPr id="2" name="box-376"/>
           <p:cNvSpPr txBox="1"/>
           <p:nvPr/>
         </p:nvSpPr>
         <p:spPr>
           <a:xfrm>
+            <a:off x="8915400" y="246888"/>
+            <a:ext cx="2862072" cy="384048"/>
+          </a:xfrm>
+          <a:prstGeom prst="rect">
+            <a:avLst/>
+          </a:prstGeom>
+          <a:solidFill>
+            <a:srgbClr val="C2255C"/>
+          </a:solidFill>
+          <a:ln/>
+        </p:spPr>
+        <p:txBody>
+          <a:bodyPr wrap="square" lIns="25400" tIns="25400" rIns="25400" bIns="25400" rtlCol="0" anchor="ctr"/>
+          <a:lstStyle/>
+          <a:p>
+            <a:pPr algn="ctr" indent="0" marL="0">
+              <a:buNone/>
+            </a:pPr>
+            <a:r>
+              <a:rPr lang="en-US" sz="1400" b="1" dirty="0">
+                <a:solidFill>
+                  <a:srgbClr val="FFFFFF"/>
+                </a:solidFill>
+              </a:rPr>
+              <a:t>Referat und Diskussion</a:t>
+            </a:r>
+            <a:endParaRPr lang="en-US" sz="1400" dirty="0"/>
+          </a:p>
+        </p:txBody>
+      </p:sp>
+      <p:sp>
+        <p:nvSpPr>
+          <p:cNvPr id="3" name="titel-377"/>
+          <p:cNvSpPr txBox="1"/>
+          <p:nvPr/>
+        </p:nvSpPr>
+        <p:spPr>
+          <a:xfrm>
             <a:off x="548640" y="896112"/>
             <a:ext cx="11094415" cy="640080"/>
           </a:xfrm>
@@ -3347,6 +3792,949 @@
                   <a:srgbClr val="14232F"/>
                 </a:solidFill>
               </a:rPr>
+              <a:t>Dein Referat oder Vortrag</a:t>
+            </a:r>
+            <a:endParaRPr lang="en-US" sz="2800" dirty="0"/>
+          </a:p>
+        </p:txBody>
+      </p:sp>
+      <p:sp>
+        <p:nvSpPr>
+          <p:cNvPr id="4" name="text-378"/>
+          <p:cNvSpPr txBox="1"/>
+          <p:nvPr/>
+        </p:nvSpPr>
+        <p:spPr>
+          <a:xfrm>
+            <a:off x="548640" y="1691640"/>
+            <a:ext cx="11094415" cy="1097280"/>
+          </a:xfrm>
+          <a:prstGeom prst="rect">
+            <a:avLst/>
+          </a:prstGeom>
+          <a:noFill/>
+          <a:ln/>
+        </p:spPr>
+        <p:txBody>
+          <a:bodyPr wrap="square" lIns="38100" tIns="38100" rIns="38100" bIns="38100" rtlCol="0" anchor="ctr"/>
+          <a:lstStyle/>
+          <a:p>
+            <a:pPr algn="ctr" indent="0" marL="0">
+              <a:buNone/>
+            </a:pPr>
+            <a:r>
+              <a:rPr lang="en-US" sz="5400" b="1" dirty="0">
+                <a:solidFill>
+                  <a:srgbClr val="035591"/>
+                </a:solidFill>
+              </a:rPr>
+              <a:t>Bühne frei</a:t>
+            </a:r>
+            <a:endParaRPr lang="en-US" sz="5400" dirty="0"/>
+          </a:p>
+        </p:txBody>
+      </p:sp>
+      <p:sp>
+        <p:nvSpPr>
+          <p:cNvPr id="5" name="step-379"/>
+          <p:cNvSpPr txBox="1"/>
+          <p:nvPr/>
+        </p:nvSpPr>
+        <p:spPr>
+          <a:xfrm>
+            <a:off x="548640" y="3200400"/>
+            <a:ext cx="1889699" cy="1737360"/>
+          </a:xfrm>
+          <a:prstGeom prst="rect">
+            <a:avLst/>
+          </a:prstGeom>
+          <a:solidFill>
+            <a:srgbClr val="FFFFFF"/>
+          </a:solidFill>
+          <a:ln w="25400">
+            <a:solidFill>
+              <a:srgbClr val="035591"/>
+            </a:solidFill>
+          </a:ln>
+        </p:spPr>
+        <p:txBody>
+          <a:bodyPr wrap="square" lIns="114300" tIns="114300" rIns="114300" bIns="114300" rtlCol="0" anchor="t"/>
+          <a:lstStyle/>
+          <a:p>
+            <a:pPr indent="0" marL="0">
+              <a:buNone/>
+            </a:pPr>
+            <a:r>
+              <a:rPr lang="en-US" sz="2000" b="1" dirty="0">
+                <a:solidFill>
+                  <a:srgbClr val="035591"/>
+                </a:solidFill>
+              </a:rPr>
+              <a:t>Einleitung</a:t>
+            </a:r>
+            <a:endParaRPr lang="en-US" sz="2000" dirty="0"/>
+          </a:p>
+          <a:p>
+            <a:pPr indent="0" marL="0">
+              <a:spcBef>
+                <a:spcPts val="400"/>
+              </a:spcBef>
+              <a:buNone/>
+            </a:pPr>
+            <a:r>
+              <a:rPr lang="en-US" sz="1600" dirty="0">
+                <a:solidFill>
+                  <a:srgbClr val="14232F"/>
+                </a:solidFill>
+              </a:rPr>
+              <a:t>Fragestellung</a:t>
+            </a:r>
+            <a:endParaRPr lang="en-US" sz="2000" dirty="0"/>
+          </a:p>
+        </p:txBody>
+      </p:sp>
+      <p:sp>
+        <p:nvSpPr>
+          <p:cNvPr id="6" name="arrow-380"/>
+          <p:cNvSpPr/>
+          <p:nvPr/>
+        </p:nvSpPr>
+        <p:spPr>
+          <a:xfrm>
+            <a:off x="2493203" y="4069080"/>
+            <a:ext cx="301752" cy="914"/>
+          </a:xfrm>
+          <a:prstGeom prst="line">
+            <a:avLst/>
+          </a:prstGeom>
+          <a:noFill/>
+          <a:ln w="25400">
+            <a:solidFill>
+              <a:srgbClr val="035591"/>
+            </a:solidFill>
+            <a:prstDash val="solid"/>
+            <a:tailEnd type="triangle"/>
+          </a:ln>
+        </p:spPr>
+      </p:sp>
+      <p:sp>
+        <p:nvSpPr>
+          <p:cNvPr id="7" name="step-381"/>
+          <p:cNvSpPr txBox="1"/>
+          <p:nvPr/>
+        </p:nvSpPr>
+        <p:spPr>
+          <a:xfrm>
+            <a:off x="2849819" y="3200400"/>
+            <a:ext cx="1889699" cy="1737360"/>
+          </a:xfrm>
+          <a:prstGeom prst="rect">
+            <a:avLst/>
+          </a:prstGeom>
+          <a:solidFill>
+            <a:srgbClr val="FFFFFF"/>
+          </a:solidFill>
+          <a:ln w="25400">
+            <a:solidFill>
+              <a:srgbClr val="035591"/>
+            </a:solidFill>
+          </a:ln>
+        </p:spPr>
+        <p:txBody>
+          <a:bodyPr wrap="square" lIns="114300" tIns="114300" rIns="114300" bIns="114300" rtlCol="0" anchor="t"/>
+          <a:lstStyle/>
+          <a:p>
+            <a:pPr indent="0" marL="0">
+              <a:buNone/>
+            </a:pPr>
+            <a:r>
+              <a:rPr lang="en-US" sz="2000" b="1" dirty="0">
+                <a:solidFill>
+                  <a:srgbClr val="035591"/>
+                </a:solidFill>
+              </a:rPr>
+              <a:t>Klärung</a:t>
+            </a:r>
+            <a:endParaRPr lang="en-US" sz="2000" dirty="0"/>
+          </a:p>
+          <a:p>
+            <a:pPr indent="0" marL="0">
+              <a:spcBef>
+                <a:spcPts val="400"/>
+              </a:spcBef>
+              <a:buNone/>
+            </a:pPr>
+            <a:r>
+              <a:rPr lang="en-US" sz="1600" dirty="0">
+                <a:solidFill>
+                  <a:srgbClr val="14232F"/>
+                </a:solidFill>
+              </a:rPr>
+              <a:t>Begriffe, Positionen</a:t>
+            </a:r>
+            <a:endParaRPr lang="en-US" sz="2000" dirty="0"/>
+          </a:p>
+        </p:txBody>
+      </p:sp>
+      <p:sp>
+        <p:nvSpPr>
+          <p:cNvPr id="8" name="arrow-382"/>
+          <p:cNvSpPr/>
+          <p:nvPr/>
+        </p:nvSpPr>
+        <p:spPr>
+          <a:xfrm>
+            <a:off x="4794382" y="4069080"/>
+            <a:ext cx="301752" cy="914"/>
+          </a:xfrm>
+          <a:prstGeom prst="line">
+            <a:avLst/>
+          </a:prstGeom>
+          <a:noFill/>
+          <a:ln w="25400">
+            <a:solidFill>
+              <a:srgbClr val="035591"/>
+            </a:solidFill>
+            <a:prstDash val="solid"/>
+            <a:tailEnd type="triangle"/>
+          </a:ln>
+        </p:spPr>
+      </p:sp>
+      <p:sp>
+        <p:nvSpPr>
+          <p:cNvPr id="9" name="step-383"/>
+          <p:cNvSpPr txBox="1"/>
+          <p:nvPr/>
+        </p:nvSpPr>
+        <p:spPr>
+          <a:xfrm>
+            <a:off x="5150998" y="3200400"/>
+            <a:ext cx="1889699" cy="1737360"/>
+          </a:xfrm>
+          <a:prstGeom prst="rect">
+            <a:avLst/>
+          </a:prstGeom>
+          <a:solidFill>
+            <a:srgbClr val="FFFFFF"/>
+          </a:solidFill>
+          <a:ln w="25400">
+            <a:solidFill>
+              <a:srgbClr val="035591"/>
+            </a:solidFill>
+          </a:ln>
+        </p:spPr>
+        <p:txBody>
+          <a:bodyPr wrap="square" lIns="114300" tIns="114300" rIns="114300" bIns="114300" rtlCol="0" anchor="t"/>
+          <a:lstStyle/>
+          <a:p>
+            <a:pPr indent="0" marL="0">
+              <a:buNone/>
+            </a:pPr>
+            <a:r>
+              <a:rPr lang="en-US" sz="2000" b="1" dirty="0">
+                <a:solidFill>
+                  <a:srgbClr val="035591"/>
+                </a:solidFill>
+              </a:rPr>
+              <a:t>Hauptteil</a:t>
+            </a:r>
+            <a:endParaRPr lang="en-US" sz="2000" dirty="0"/>
+          </a:p>
+          <a:p>
+            <a:pPr indent="0" marL="0">
+              <a:spcBef>
+                <a:spcPts val="400"/>
+              </a:spcBef>
+              <a:buNone/>
+            </a:pPr>
+            <a:r>
+              <a:rPr lang="en-US" sz="1600" dirty="0">
+                <a:solidFill>
+                  <a:srgbClr val="14232F"/>
+                </a:solidFill>
+              </a:rPr>
+              <a:t>Quellen, Praxis, Kritik</a:t>
+            </a:r>
+            <a:endParaRPr lang="en-US" sz="2000" dirty="0"/>
+          </a:p>
+        </p:txBody>
+      </p:sp>
+      <p:sp>
+        <p:nvSpPr>
+          <p:cNvPr id="10" name="arrow-384"/>
+          <p:cNvSpPr/>
+          <p:nvPr/>
+        </p:nvSpPr>
+        <p:spPr>
+          <a:xfrm>
+            <a:off x="7095561" y="4069080"/>
+            <a:ext cx="301752" cy="914"/>
+          </a:xfrm>
+          <a:prstGeom prst="line">
+            <a:avLst/>
+          </a:prstGeom>
+          <a:noFill/>
+          <a:ln w="25400">
+            <a:solidFill>
+              <a:srgbClr val="035591"/>
+            </a:solidFill>
+            <a:prstDash val="solid"/>
+            <a:tailEnd type="triangle"/>
+          </a:ln>
+        </p:spPr>
+      </p:sp>
+      <p:sp>
+        <p:nvSpPr>
+          <p:cNvPr id="11" name="step-385"/>
+          <p:cNvSpPr txBox="1"/>
+          <p:nvPr/>
+        </p:nvSpPr>
+        <p:spPr>
+          <a:xfrm>
+            <a:off x="7452177" y="3200400"/>
+            <a:ext cx="1889699" cy="1737360"/>
+          </a:xfrm>
+          <a:prstGeom prst="rect">
+            <a:avLst/>
+          </a:prstGeom>
+          <a:solidFill>
+            <a:srgbClr val="FFFFFF"/>
+          </a:solidFill>
+          <a:ln w="25400">
+            <a:solidFill>
+              <a:srgbClr val="035591"/>
+            </a:solidFill>
+          </a:ln>
+        </p:spPr>
+        <p:txBody>
+          <a:bodyPr wrap="square" lIns="114300" tIns="114300" rIns="114300" bIns="114300" rtlCol="0" anchor="t"/>
+          <a:lstStyle/>
+          <a:p>
+            <a:pPr indent="0" marL="0">
+              <a:buNone/>
+            </a:pPr>
+            <a:r>
+              <a:rPr lang="en-US" sz="2000" b="1" dirty="0">
+                <a:solidFill>
+                  <a:srgbClr val="035591"/>
+                </a:solidFill>
+              </a:rPr>
+              <a:t>Fazit</a:t>
+            </a:r>
+            <a:endParaRPr lang="en-US" sz="2000" dirty="0"/>
+          </a:p>
+          <a:p>
+            <a:pPr indent="0" marL="0">
+              <a:spcBef>
+                <a:spcPts val="400"/>
+              </a:spcBef>
+              <a:buNone/>
+            </a:pPr>
+            <a:r>
+              <a:rPr lang="en-US" sz="1600" dirty="0">
+                <a:solidFill>
+                  <a:srgbClr val="14232F"/>
+                </a:solidFill>
+              </a:rPr>
+              <a:t>Ansätze für die Diskussion</a:t>
+            </a:r>
+            <a:endParaRPr lang="en-US" sz="2000" dirty="0"/>
+          </a:p>
+        </p:txBody>
+      </p:sp>
+      <p:sp>
+        <p:nvSpPr>
+          <p:cNvPr id="12" name="arrow-386"/>
+          <p:cNvSpPr/>
+          <p:nvPr/>
+        </p:nvSpPr>
+        <p:spPr>
+          <a:xfrm>
+            <a:off x="9396740" y="4069080"/>
+            <a:ext cx="301752" cy="914"/>
+          </a:xfrm>
+          <a:prstGeom prst="line">
+            <a:avLst/>
+          </a:prstGeom>
+          <a:noFill/>
+          <a:ln w="25400">
+            <a:solidFill>
+              <a:srgbClr val="035591"/>
+            </a:solidFill>
+            <a:prstDash val="solid"/>
+            <a:tailEnd type="triangle"/>
+          </a:ln>
+        </p:spPr>
+      </p:sp>
+      <p:sp>
+        <p:nvSpPr>
+          <p:cNvPr id="13" name="step-387"/>
+          <p:cNvSpPr txBox="1"/>
+          <p:nvPr/>
+        </p:nvSpPr>
+        <p:spPr>
+          <a:xfrm>
+            <a:off x="9753356" y="3200400"/>
+            <a:ext cx="1889699" cy="1737360"/>
+          </a:xfrm>
+          <a:prstGeom prst="rect">
+            <a:avLst/>
+          </a:prstGeom>
+          <a:solidFill>
+            <a:srgbClr val="FFFFFF"/>
+          </a:solidFill>
+          <a:ln w="25400">
+            <a:solidFill>
+              <a:srgbClr val="035591"/>
+            </a:solidFill>
+          </a:ln>
+        </p:spPr>
+        <p:txBody>
+          <a:bodyPr wrap="square" lIns="114300" tIns="114300" rIns="114300" bIns="114300" rtlCol="0" anchor="t"/>
+          <a:lstStyle/>
+          <a:p>
+            <a:pPr indent="0" marL="0">
+              <a:buNone/>
+            </a:pPr>
+            <a:r>
+              <a:rPr lang="en-US" sz="2000" b="1" dirty="0">
+                <a:solidFill>
+                  <a:srgbClr val="035591"/>
+                </a:solidFill>
+              </a:rPr>
+              <a:t>Diskussion</a:t>
+            </a:r>
+            <a:endParaRPr lang="en-US" sz="2000" dirty="0"/>
+          </a:p>
+          <a:p>
+            <a:pPr indent="0" marL="0">
+              <a:spcBef>
+                <a:spcPts val="400"/>
+              </a:spcBef>
+              <a:buNone/>
+            </a:pPr>
+            <a:r>
+              <a:rPr lang="en-US" sz="1600" dirty="0">
+                <a:solidFill>
+                  <a:srgbClr val="14232F"/>
+                </a:solidFill>
+              </a:rPr>
+              <a:t>Fragen mit Impulsen</a:t>
+            </a:r>
+            <a:endParaRPr lang="en-US" sz="2000" dirty="0"/>
+          </a:p>
+        </p:txBody>
+      </p:sp>
+      <p:sp>
+        <p:nvSpPr>
+          <p:cNvPr id="25" name="Slide Number Placeholder 0"/>
+          <p:cNvSpPr>
+            <a:spLocks noGrp="1"/>
+          </p:cNvSpPr>
+          <p:nvPr>
+            <p:ph type="sldNum" sz="quarter" idx="4294967295"/>
+          </p:nvPr>
+        </p:nvSpPr>
+        <p:spPr>
+          <a:xfrm>
+            <a:off x="11247120" y="6473952"/>
+            <a:ext cx="548640" cy="274320"/>
+          </a:xfrm>
+          <a:prstGeom prst="rect">
+            <a:avLst/>
+          </a:prstGeom>
+          <a:extLst>
+            <a:ext uri="{C572A759-6A51-4108-AA02-DFA0A04FC94B}">
+              <ma14:wrappingTextBoxFlag xmlns:ma14="http://schemas.microsoft.com/office/mac/drawingml/2011/main" val="0"/>
+            </a:ext>
+          </a:extLst>
+        </p:spPr>
+        <p:txBody>
+          <a:bodyPr/>
+          <a:lstStyle>
+            <a:lvl1pPr>
+              <a:defRPr sz="1000">
+                <a:solidFill>
+                  <a:srgbClr val="56687A"/>
+                </a:solidFill>
+              </a:defRPr>
+            </a:lvl1pPr>
+          </a:lstStyle>
+          <a:p>
+            <a:pPr algn="r"/>
+            <a:fld id="{F7021451-1387-4CA6-816F-3879F97B5CBC}" type="slidenum">
+              <a:rPr b="0" lang="en-US"/>
+              <a:t>5</a:t>
+            </a:fld>
+            <a:endParaRPr lang="en-US"/>
+          </a:p>
+        </p:txBody>
+      </p:sp>
+    </p:spTree>
+  </p:cSld>
+  <p:clrMapOvr>
+    <a:masterClrMapping/>
+  </p:clrMapOvr>
+</p:sld>
+</file>
+
+<file path=ppt/slides/slide6.xml><?xml version="1.0" encoding="utf-8"?>
+<p:sld xmlns:a="http://schemas.openxmlformats.org/drawingml/2006/main" xmlns:r="http://schemas.openxmlformats.org/officeDocument/2006/relationships" xmlns:p="http://schemas.openxmlformats.org/presentationml/2006/main">
+  <p:cSld name="Slide 6">
+    <p:spTree>
+      <p:nvGrpSpPr>
+        <p:cNvPr id="1" name=""/>
+        <p:cNvGrpSpPr/>
+        <p:nvPr/>
+      </p:nvGrpSpPr>
+      <p:grpSpPr>
+        <a:xfrm>
+          <a:off x="0" y="0"/>
+          <a:ext cx="0" cy="0"/>
+          <a:chOff x="0" y="0"/>
+          <a:chExt cx="0" cy="0"/>
+        </a:xfrm>
+      </p:grpSpPr>
+      <p:sp>
+        <p:nvSpPr>
+          <p:cNvPr id="2" name="box-388"/>
+          <p:cNvSpPr txBox="1"/>
+          <p:nvPr/>
+        </p:nvSpPr>
+        <p:spPr>
+          <a:xfrm>
+            <a:off x="8915400" y="246888"/>
+            <a:ext cx="2862072" cy="384048"/>
+          </a:xfrm>
+          <a:prstGeom prst="rect">
+            <a:avLst/>
+          </a:prstGeom>
+          <a:solidFill>
+            <a:srgbClr val="C2255C"/>
+          </a:solidFill>
+          <a:ln/>
+        </p:spPr>
+        <p:txBody>
+          <a:bodyPr wrap="square" lIns="25400" tIns="25400" rIns="25400" bIns="25400" rtlCol="0" anchor="ctr"/>
+          <a:lstStyle/>
+          <a:p>
+            <a:pPr algn="ctr" indent="0" marL="0">
+              <a:buNone/>
+            </a:pPr>
+            <a:r>
+              <a:rPr lang="en-US" sz="1400" b="1" dirty="0">
+                <a:solidFill>
+                  <a:srgbClr val="FFFFFF"/>
+                </a:solidFill>
+              </a:rPr>
+              <a:t>Referat und Diskussion</a:t>
+            </a:r>
+            <a:endParaRPr lang="en-US" sz="1400" dirty="0"/>
+          </a:p>
+        </p:txBody>
+      </p:sp>
+      <p:sp>
+        <p:nvSpPr>
+          <p:cNvPr id="3" name="titel-389"/>
+          <p:cNvSpPr txBox="1"/>
+          <p:nvPr/>
+        </p:nvSpPr>
+        <p:spPr>
+          <a:xfrm>
+            <a:off x="548640" y="896112"/>
+            <a:ext cx="11094415" cy="640080"/>
+          </a:xfrm>
+          <a:prstGeom prst="rect">
+            <a:avLst/>
+          </a:prstGeom>
+          <a:noFill/>
+          <a:ln/>
+        </p:spPr>
+        <p:txBody>
+          <a:bodyPr wrap="square" lIns="0" tIns="0" rIns="0" bIns="0" rtlCol="0" anchor="ctr"/>
+          <a:lstStyle/>
+          <a:p>
+            <a:pPr indent="0" marL="0">
+              <a:buNone/>
+            </a:pPr>
+            <a:r>
+              <a:rPr lang="en-US" sz="2800" b="1" dirty="0">
+                <a:solidFill>
+                  <a:srgbClr val="14232F"/>
+                </a:solidFill>
+              </a:rPr>
+              <a:t>Diskussion</a:t>
+            </a:r>
+            <a:endParaRPr lang="en-US" sz="2800" dirty="0"/>
+          </a:p>
+        </p:txBody>
+      </p:sp>
+      <p:sp>
+        <p:nvSpPr>
+          <p:cNvPr id="4" name="box-390"/>
+          <p:cNvSpPr txBox="1"/>
+          <p:nvPr/>
+        </p:nvSpPr>
+        <p:spPr>
+          <a:xfrm>
+            <a:off x="548640" y="1691640"/>
+            <a:ext cx="822960" cy="1097280"/>
+          </a:xfrm>
+          <a:prstGeom prst="rect">
+            <a:avLst/>
+          </a:prstGeom>
+          <a:solidFill>
+            <a:srgbClr val="035591"/>
+          </a:solidFill>
+          <a:ln/>
+        </p:spPr>
+        <p:txBody>
+          <a:bodyPr wrap="square" lIns="101600" tIns="101600" rIns="101600" bIns="101600" rtlCol="0" anchor="ctr"/>
+          <a:lstStyle/>
+          <a:p>
+            <a:pPr algn="ctr" indent="0" marL="0">
+              <a:buNone/>
+            </a:pPr>
+            <a:r>
+              <a:rPr lang="en-US" sz="3200" b="1" dirty="0">
+                <a:solidFill>
+                  <a:srgbClr val="FFFFFF"/>
+                </a:solidFill>
+              </a:rPr>
+              <a:t>?</a:t>
+            </a:r>
+            <a:endParaRPr lang="en-US" sz="3200" dirty="0"/>
+          </a:p>
+        </p:txBody>
+      </p:sp>
+      <p:sp>
+        <p:nvSpPr>
+          <p:cNvPr id="5" name="box-391"/>
+          <p:cNvSpPr txBox="1"/>
+          <p:nvPr/>
+        </p:nvSpPr>
+        <p:spPr>
+          <a:xfrm>
+            <a:off x="1508760" y="1691640"/>
+            <a:ext cx="10134295" cy="1097280"/>
+          </a:xfrm>
+          <a:prstGeom prst="rect">
+            <a:avLst/>
+          </a:prstGeom>
+          <a:solidFill>
+            <a:srgbClr val="EEF3F7"/>
+          </a:solidFill>
+          <a:ln/>
+        </p:spPr>
+        <p:txBody>
+          <a:bodyPr wrap="square" lIns="101600" tIns="101600" rIns="101600" bIns="101600" rtlCol="0" anchor="ctr"/>
+          <a:lstStyle/>
+          <a:p>
+            <a:pPr algn="l" indent="0" marL="0">
+              <a:buNone/>
+            </a:pPr>
+            <a:r>
+              <a:rPr lang="en-US" sz="2400" dirty="0">
+                <a:solidFill>
+                  <a:srgbClr val="14232F"/>
+                </a:solidFill>
+              </a:rPr>
+              <a:t>Deine Diskussionsfragen mit Impulsen</a:t>
+            </a:r>
+            <a:endParaRPr lang="en-US" sz="2400" dirty="0"/>
+          </a:p>
+        </p:txBody>
+      </p:sp>
+      <p:sp>
+        <p:nvSpPr>
+          <p:cNvPr id="6" name="box-392"/>
+          <p:cNvSpPr txBox="1"/>
+          <p:nvPr/>
+        </p:nvSpPr>
+        <p:spPr>
+          <a:xfrm>
+            <a:off x="548640" y="3017520"/>
+            <a:ext cx="822960" cy="1097280"/>
+          </a:xfrm>
+          <a:prstGeom prst="rect">
+            <a:avLst/>
+          </a:prstGeom>
+          <a:solidFill>
+            <a:srgbClr val="035591"/>
+          </a:solidFill>
+          <a:ln/>
+        </p:spPr>
+        <p:txBody>
+          <a:bodyPr wrap="square" lIns="101600" tIns="101600" rIns="101600" bIns="101600" rtlCol="0" anchor="ctr"/>
+          <a:lstStyle/>
+          <a:p>
+            <a:pPr algn="ctr" indent="0" marL="0">
+              <a:buNone/>
+            </a:pPr>
+            <a:r>
+              <a:rPr lang="en-US" sz="3200" b="1" dirty="0">
+                <a:solidFill>
+                  <a:srgbClr val="FFFFFF"/>
+                </a:solidFill>
+              </a:rPr>
+              <a:t>?</a:t>
+            </a:r>
+            <a:endParaRPr lang="en-US" sz="3200" dirty="0"/>
+          </a:p>
+        </p:txBody>
+      </p:sp>
+      <p:sp>
+        <p:nvSpPr>
+          <p:cNvPr id="7" name="box-393"/>
+          <p:cNvSpPr txBox="1"/>
+          <p:nvPr/>
+        </p:nvSpPr>
+        <p:spPr>
+          <a:xfrm>
+            <a:off x="1508760" y="3017520"/>
+            <a:ext cx="10134295" cy="1097280"/>
+          </a:xfrm>
+          <a:prstGeom prst="rect">
+            <a:avLst/>
+          </a:prstGeom>
+          <a:solidFill>
+            <a:srgbClr val="EEF3F7"/>
+          </a:solidFill>
+          <a:ln/>
+        </p:spPr>
+        <p:txBody>
+          <a:bodyPr wrap="square" lIns="101600" tIns="101600" rIns="101600" bIns="101600" rtlCol="0" anchor="ctr"/>
+          <a:lstStyle/>
+          <a:p>
+            <a:pPr algn="l" indent="0" marL="0">
+              <a:buNone/>
+            </a:pPr>
+            <a:r>
+              <a:rPr lang="en-US" sz="2400" dirty="0">
+                <a:solidFill>
+                  <a:srgbClr val="14232F"/>
+                </a:solidFill>
+              </a:rPr>
+              <a:t>Wo klaffen Wissenschaft und Schulpraxis auseinander?</a:t>
+            </a:r>
+            <a:endParaRPr lang="en-US" sz="2400" dirty="0"/>
+          </a:p>
+        </p:txBody>
+      </p:sp>
+      <p:sp>
+        <p:nvSpPr>
+          <p:cNvPr id="8" name="box-394"/>
+          <p:cNvSpPr txBox="1"/>
+          <p:nvPr/>
+        </p:nvSpPr>
+        <p:spPr>
+          <a:xfrm>
+            <a:off x="548640" y="4343400"/>
+            <a:ext cx="822960" cy="1097280"/>
+          </a:xfrm>
+          <a:prstGeom prst="rect">
+            <a:avLst/>
+          </a:prstGeom>
+          <a:solidFill>
+            <a:srgbClr val="035591"/>
+          </a:solidFill>
+          <a:ln/>
+        </p:spPr>
+        <p:txBody>
+          <a:bodyPr wrap="square" lIns="101600" tIns="101600" rIns="101600" bIns="101600" rtlCol="0" anchor="ctr"/>
+          <a:lstStyle/>
+          <a:p>
+            <a:pPr algn="ctr" indent="0" marL="0">
+              <a:buNone/>
+            </a:pPr>
+            <a:r>
+              <a:rPr lang="en-US" sz="3200" b="1" dirty="0">
+                <a:solidFill>
+                  <a:srgbClr val="FFFFFF"/>
+                </a:solidFill>
+              </a:rPr>
+              <a:t>?</a:t>
+            </a:r>
+            <a:endParaRPr lang="en-US" sz="3200" dirty="0"/>
+          </a:p>
+        </p:txBody>
+      </p:sp>
+      <p:sp>
+        <p:nvSpPr>
+          <p:cNvPr id="9" name="box-395"/>
+          <p:cNvSpPr txBox="1"/>
+          <p:nvPr/>
+        </p:nvSpPr>
+        <p:spPr>
+          <a:xfrm>
+            <a:off x="1508760" y="4343400"/>
+            <a:ext cx="10134295" cy="1097280"/>
+          </a:xfrm>
+          <a:prstGeom prst="rect">
+            <a:avLst/>
+          </a:prstGeom>
+          <a:solidFill>
+            <a:srgbClr val="EEF3F7"/>
+          </a:solidFill>
+          <a:ln/>
+        </p:spPr>
+        <p:txBody>
+          <a:bodyPr wrap="square" lIns="101600" tIns="101600" rIns="101600" bIns="101600" rtlCol="0" anchor="ctr"/>
+          <a:lstStyle/>
+          <a:p>
+            <a:pPr algn="l" indent="0" marL="0">
+              <a:buNone/>
+            </a:pPr>
+            <a:r>
+              <a:rPr lang="en-US" sz="2400" dirty="0">
+                <a:solidFill>
+                  <a:srgbClr val="14232F"/>
+                </a:solidFill>
+              </a:rPr>
+              <a:t>Was bedeutet das für deinen späteren Technikunterricht?</a:t>
+            </a:r>
+            <a:endParaRPr lang="en-US" sz="2400" dirty="0"/>
+          </a:p>
+        </p:txBody>
+      </p:sp>
+      <p:sp>
+        <p:nvSpPr>
+          <p:cNvPr id="25" name="Slide Number Placeholder 0"/>
+          <p:cNvSpPr>
+            <a:spLocks noGrp="1"/>
+          </p:cNvSpPr>
+          <p:nvPr>
+            <p:ph type="sldNum" sz="quarter" idx="4294967295"/>
+          </p:nvPr>
+        </p:nvSpPr>
+        <p:spPr>
+          <a:xfrm>
+            <a:off x="11247120" y="6473952"/>
+            <a:ext cx="548640" cy="274320"/>
+          </a:xfrm>
+          <a:prstGeom prst="rect">
+            <a:avLst/>
+          </a:prstGeom>
+          <a:extLst>
+            <a:ext uri="{C572A759-6A51-4108-AA02-DFA0A04FC94B}">
+              <ma14:wrappingTextBoxFlag xmlns:ma14="http://schemas.microsoft.com/office/mac/drawingml/2011/main" val="0"/>
+            </a:ext>
+          </a:extLst>
+        </p:spPr>
+        <p:txBody>
+          <a:bodyPr/>
+          <a:lstStyle>
+            <a:lvl1pPr>
+              <a:defRPr sz="1000">
+                <a:solidFill>
+                  <a:srgbClr val="56687A"/>
+                </a:solidFill>
+              </a:defRPr>
+            </a:lvl1pPr>
+          </a:lstStyle>
+          <a:p>
+            <a:pPr algn="r"/>
+            <a:fld id="{F7021451-1387-4CA6-816F-3879F97B5CBC}" type="slidenum">
+              <a:rPr b="0" lang="en-US"/>
+              <a:t>6</a:t>
+            </a:fld>
+            <a:endParaRPr lang="en-US"/>
+          </a:p>
+        </p:txBody>
+      </p:sp>
+    </p:spTree>
+  </p:cSld>
+  <p:clrMapOvr>
+    <a:masterClrMapping/>
+  </p:clrMapOvr>
+</p:sld>
+</file>
+
+<file path=ppt/slides/slide7.xml><?xml version="1.0" encoding="utf-8"?>
+<p:sld xmlns:a="http://schemas.openxmlformats.org/drawingml/2006/main" xmlns:r="http://schemas.openxmlformats.org/officeDocument/2006/relationships" xmlns:p="http://schemas.openxmlformats.org/presentationml/2006/main">
+  <p:cSld name="Slide 7">
+    <p:spTree>
+      <p:nvGrpSpPr>
+        <p:cNvPr id="1" name=""/>
+        <p:cNvGrpSpPr/>
+        <p:nvPr/>
+      </p:nvGrpSpPr>
+      <p:grpSpPr>
+        <a:xfrm>
+          <a:off x="0" y="0"/>
+          <a:ext cx="0" cy="0"/>
+          <a:chOff x="0" y="0"/>
+          <a:chExt cx="0" cy="0"/>
+        </a:xfrm>
+      </p:grpSpPr>
+      <p:sp>
+        <p:nvSpPr>
+          <p:cNvPr id="2" name="box-396"/>
+          <p:cNvSpPr txBox="1"/>
+          <p:nvPr/>
+        </p:nvSpPr>
+        <p:spPr>
+          <a:xfrm>
+            <a:off x="8915400" y="246888"/>
+            <a:ext cx="2862072" cy="384048"/>
+          </a:xfrm>
+          <a:prstGeom prst="rect">
+            <a:avLst/>
+          </a:prstGeom>
+          <a:solidFill>
+            <a:srgbClr val="C2255C"/>
+          </a:solidFill>
+          <a:ln/>
+        </p:spPr>
+        <p:txBody>
+          <a:bodyPr wrap="square" lIns="25400" tIns="25400" rIns="25400" bIns="25400" rtlCol="0" anchor="ctr"/>
+          <a:lstStyle/>
+          <a:p>
+            <a:pPr algn="ctr" indent="0" marL="0">
+              <a:buNone/>
+            </a:pPr>
+            <a:r>
+              <a:rPr lang="en-US" sz="1400" b="1" dirty="0">
+                <a:solidFill>
+                  <a:srgbClr val="FFFFFF"/>
+                </a:solidFill>
+              </a:rPr>
+              <a:t>Referat und Diskussion</a:t>
+            </a:r>
+            <a:endParaRPr lang="en-US" sz="1400" dirty="0"/>
+          </a:p>
+        </p:txBody>
+      </p:sp>
+      <p:sp>
+        <p:nvSpPr>
+          <p:cNvPr id="3" name="titel-397"/>
+          <p:cNvSpPr txBox="1"/>
+          <p:nvPr/>
+        </p:nvSpPr>
+        <p:spPr>
+          <a:xfrm>
+            <a:off x="548640" y="896112"/>
+            <a:ext cx="11094415" cy="640080"/>
+          </a:xfrm>
+          <a:prstGeom prst="rect">
+            <a:avLst/>
+          </a:prstGeom>
+          <a:noFill/>
+          <a:ln/>
+        </p:spPr>
+        <p:txBody>
+          <a:bodyPr wrap="square" lIns="0" tIns="0" rIns="0" bIns="0" rtlCol="0" anchor="ctr"/>
+          <a:lstStyle/>
+          <a:p>
+            <a:pPr indent="0" marL="0">
+              <a:buNone/>
+            </a:pPr>
+            <a:r>
+              <a:rPr lang="en-US" sz="2800" b="1" dirty="0">
+                <a:solidFill>
+                  <a:srgbClr val="14232F"/>
+                </a:solidFill>
+              </a:rPr>
               <a:t>Bewertungsgrundlagen</a:t>
             </a:r>
             <a:endParaRPr lang="en-US" sz="2800" dirty="0"/>
@@ -3355,7 +4743,7 @@
       </p:sp>
       <p:graphicFrame>
         <p:nvGraphicFramePr>
-          <p:cNvPr id="6" name="table-287"/>
+          <p:cNvPr id="8" name="table-398"/>
           <p:cNvGraphicFramePr>
             <a:graphicFrameLocks noGrp="1"/>
           </p:cNvGraphicFramePr>
@@ -4493,7 +5881,7 @@
       </p:graphicFrame>
       <p:graphicFrame>
         <p:nvGraphicFramePr>
-          <p:cNvPr id="11" name="table-288"/>
+          <p:cNvPr id="15" name="table-399"/>
           <p:cNvGraphicFramePr>
             <a:graphicFrameLocks noGrp="1"/>
           </p:cNvGraphicFramePr>
@@ -5383,7 +6771,7 @@
       </p:graphicFrame>
       <p:sp>
         <p:nvSpPr>
-          <p:cNvPr id="5" name="text-289"/>
+          <p:cNvPr id="6" name="text-400"/>
           <p:cNvSpPr txBox="1"/>
           <p:nvPr/>
         </p:nvSpPr>
@@ -5456,7 +6844,7 @@
             <a:pPr algn="r"/>
             <a:fld id="{F7021451-1387-4CA6-816F-3879F97B5CBC}" type="slidenum">
               <a:rPr b="0" lang="en-US"/>
-              <a:t>5</a:t>
+              <a:t>7</a:t>
             </a:fld>
             <a:endParaRPr lang="en-US"/>
           </a:p>
@@ -5470,9 +6858,9 @@
 </p:sld>
 </file>
 
-<file path=ppt/slides/slide6.xml><?xml version="1.0" encoding="utf-8"?>
+<file path=ppt/slides/slide8.xml><?xml version="1.0" encoding="utf-8"?>
 <p:sld xmlns:a="http://schemas.openxmlformats.org/drawingml/2006/main" xmlns:r="http://schemas.openxmlformats.org/officeDocument/2006/relationships" xmlns:p="http://schemas.openxmlformats.org/presentationml/2006/main">
-  <p:cSld name="Slide 6">
+  <p:cSld name="Slide 8">
     <p:spTree>
       <p:nvGrpSpPr>
         <p:cNvPr id="1" name=""/>
@@ -5489,12 +6877,50 @@
       </p:grpSpPr>
       <p:sp>
         <p:nvSpPr>
-          <p:cNvPr id="2" name="titel-290"/>
+          <p:cNvPr id="2" name="box-401"/>
           <p:cNvSpPr txBox="1"/>
           <p:nvPr/>
         </p:nvSpPr>
         <p:spPr>
           <a:xfrm>
+            <a:off x="8915400" y="246888"/>
+            <a:ext cx="2862072" cy="384048"/>
+          </a:xfrm>
+          <a:prstGeom prst="rect">
+            <a:avLst/>
+          </a:prstGeom>
+          <a:solidFill>
+            <a:srgbClr val="C2255C"/>
+          </a:solidFill>
+          <a:ln/>
+        </p:spPr>
+        <p:txBody>
+          <a:bodyPr wrap="square" lIns="25400" tIns="25400" rIns="25400" bIns="25400" rtlCol="0" anchor="ctr"/>
+          <a:lstStyle/>
+          <a:p>
+            <a:pPr algn="ctr" indent="0" marL="0">
+              <a:buNone/>
+            </a:pPr>
+            <a:r>
+              <a:rPr lang="en-US" sz="1400" b="1" dirty="0">
+                <a:solidFill>
+                  <a:srgbClr val="FFFFFF"/>
+                </a:solidFill>
+              </a:rPr>
+              <a:t>Referat und Diskussion</a:t>
+            </a:r>
+            <a:endParaRPr lang="en-US" sz="1400" dirty="0"/>
+          </a:p>
+        </p:txBody>
+      </p:sp>
+      <p:sp>
+        <p:nvSpPr>
+          <p:cNvPr id="3" name="titel-402"/>
+          <p:cNvSpPr txBox="1"/>
+          <p:nvPr/>
+        </p:nvSpPr>
+        <p:spPr>
+          <a:xfrm>
             <a:off x="548640" y="896112"/>
             <a:ext cx="11094415" cy="640080"/>
           </a:xfrm>
@@ -5525,7 +6951,7 @@
       </p:sp>
       <p:sp>
         <p:nvSpPr>
-          <p:cNvPr id="3" name="tile-291"/>
+          <p:cNvPr id="4" name="tile-403"/>
           <p:cNvSpPr txBox="1"/>
           <p:nvPr/>
         </p:nvSpPr>
@@ -5584,7 +7010,7 @@
       </p:sp>
       <p:sp>
         <p:nvSpPr>
-          <p:cNvPr id="4" name="tile-292"/>
+          <p:cNvPr id="5" name="tile-404"/>
           <p:cNvSpPr txBox="1"/>
           <p:nvPr/>
         </p:nvSpPr>
@@ -5643,7 +7069,7 @@
       </p:sp>
       <p:sp>
         <p:nvSpPr>
-          <p:cNvPr id="5" name="tile-293"/>
+          <p:cNvPr id="6" name="tile-405"/>
           <p:cNvSpPr txBox="1"/>
           <p:nvPr/>
         </p:nvSpPr>
@@ -5702,7 +7128,7 @@
       </p:sp>
       <p:sp>
         <p:nvSpPr>
-          <p:cNvPr id="6" name="tile-294"/>
+          <p:cNvPr id="7" name="tile-406"/>
           <p:cNvSpPr txBox="1"/>
           <p:nvPr/>
         </p:nvSpPr>
@@ -5798,7 +7224,7 @@
             <a:pPr algn="r"/>
             <a:fld id="{F7021451-1387-4CA6-816F-3879F97B5CBC}" type="slidenum">
               <a:rPr b="0" lang="en-US"/>
-              <a:t>6</a:t>
+              <a:t>8</a:t>
             </a:fld>
             <a:endParaRPr lang="en-US"/>
           </a:p>
@@ -5812,9 +7238,16 @@
 </p:sld>
 </file>
 
-<file path=ppt/slides/slide7.xml><?xml version="1.0" encoding="utf-8"?>
+<file path=ppt/slides/slide9.xml><?xml version="1.0" encoding="utf-8"?>
 <p:sld xmlns:a="http://schemas.openxmlformats.org/drawingml/2006/main" xmlns:r="http://schemas.openxmlformats.org/officeDocument/2006/relationships" xmlns:p="http://schemas.openxmlformats.org/presentationml/2006/main">
-  <p:cSld name="Slide 7">
+  <p:cSld name="Slide 9">
+    <p:bg>
+      <p:bgPr>
+        <a:solidFill>
+          <a:srgbClr val="FFF3C9"/>
+        </a:solidFill>
+      </p:bgPr>
+    </p:bg>
     <p:spTree>
       <p:nvGrpSpPr>
         <p:cNvPr id="1" name=""/>
@@ -5831,14 +7264,72 @@
       </p:grpSpPr>
       <p:sp>
         <p:nvSpPr>
-          <p:cNvPr id="2" name="titel-295"/>
+          <p:cNvPr id="2" name="band-407"/>
+          <p:cNvSpPr/>
+          <p:nvPr/>
+        </p:nvSpPr>
+        <p:spPr>
+          <a:xfrm>
+            <a:off x="0" y="0"/>
+            <a:ext cx="320040" cy="6858000"/>
+          </a:xfrm>
+          <a:prstGeom prst="rect">
+            <a:avLst/>
+          </a:prstGeom>
+          <a:solidFill>
+            <a:srgbClr val="F5B700"/>
+          </a:solidFill>
+          <a:ln/>
+        </p:spPr>
+      </p:sp>
+      <p:sp>
+        <p:nvSpPr>
+          <p:cNvPr id="3" name="box-408"/>
           <p:cNvSpPr txBox="1"/>
           <p:nvPr/>
         </p:nvSpPr>
         <p:spPr>
           <a:xfrm>
-            <a:off x="548640" y="896112"/>
-            <a:ext cx="11094415" cy="640080"/>
+            <a:off x="822960" y="1463040"/>
+            <a:ext cx="5852160" cy="640080"/>
+          </a:xfrm>
+          <a:prstGeom prst="rect">
+            <a:avLst/>
+          </a:prstGeom>
+          <a:solidFill>
+            <a:srgbClr val="F5B700"/>
+          </a:solidFill>
+          <a:ln/>
+        </p:spPr>
+        <p:txBody>
+          <a:bodyPr wrap="square" lIns="101600" tIns="101600" rIns="101600" bIns="101600" rtlCol="0" anchor="ctr"/>
+          <a:lstStyle/>
+          <a:p>
+            <a:pPr algn="ctr" indent="0" marL="0">
+              <a:buNone/>
+            </a:pPr>
+            <a:r>
+              <a:rPr lang="en-US" sz="2400" b="1" dirty="0">
+                <a:solidFill>
+                  <a:srgbClr val="14232F"/>
+                </a:solidFill>
+              </a:rPr>
+              <a:t>AUFGABEN FÜR ZU HAUSE</a:t>
+            </a:r>
+            <a:endParaRPr lang="en-US" sz="2400" dirty="0"/>
+          </a:p>
+        </p:txBody>
+      </p:sp>
+      <p:sp>
+        <p:nvSpPr>
+          <p:cNvPr id="4" name="titel-409"/>
+          <p:cNvSpPr txBox="1"/>
+          <p:nvPr/>
+        </p:nvSpPr>
+        <p:spPr>
+          <a:xfrm>
+            <a:off x="822960" y="2377440"/>
+            <a:ext cx="10607040" cy="1828800"/>
           </a:xfrm>
           <a:prstGeom prst="rect">
             <a:avLst/>
@@ -5847,152 +7338,34 @@
           <a:ln/>
         </p:spPr>
         <p:txBody>
-          <a:bodyPr wrap="square" lIns="0" tIns="0" rIns="0" bIns="0" rtlCol="0" anchor="ctr"/>
+          <a:bodyPr wrap="square" lIns="0" tIns="0" rIns="0" bIns="0" rtlCol="0" anchor="t"/>
           <a:lstStyle/>
           <a:p>
             <a:pPr indent="0" marL="0">
               <a:buNone/>
             </a:pPr>
             <a:r>
-              <a:rPr lang="en-US" sz="2800" b="1" dirty="0">
+              <a:rPr lang="en-US" sz="4000" b="1" dirty="0">
                 <a:solidFill>
                   <a:srgbClr val="14232F"/>
                 </a:solidFill>
               </a:rPr>
-              <a:t>Nach Termin 4: Ausarbeitung</a:t>
-            </a:r>
-            <a:endParaRPr lang="en-US" sz="2800" dirty="0"/>
-          </a:p>
-        </p:txBody>
-      </p:sp>
-      <p:sp>
-        <p:nvSpPr>
-          <p:cNvPr id="3" name="tile-296"/>
+              <a:t>Aufgabenpaket 4: Diskussionsergebnisse und Ausarbeitung</a:t>
+            </a:r>
+            <a:endParaRPr lang="en-US" sz="4000" dirty="0"/>
+          </a:p>
+        </p:txBody>
+      </p:sp>
+      <p:sp>
+        <p:nvSpPr>
+          <p:cNvPr id="5" name="text-410"/>
           <p:cNvSpPr txBox="1"/>
           <p:nvPr/>
         </p:nvSpPr>
         <p:spPr>
           <a:xfrm>
-            <a:off x="548640" y="1600200"/>
-            <a:ext cx="5440680" cy="2011680"/>
-          </a:xfrm>
-          <a:prstGeom prst="rect">
-            <a:avLst/>
-          </a:prstGeom>
-          <a:solidFill>
-            <a:srgbClr val="FFF3C9"/>
-          </a:solidFill>
-          <a:ln w="6350">
-            <a:solidFill>
-              <a:srgbClr val="FFF3C9"/>
-            </a:solidFill>
-          </a:ln>
-        </p:spPr>
-        <p:txBody>
-          <a:bodyPr wrap="square" lIns="127000" tIns="127000" rIns="127000" bIns="127000" rtlCol="0" anchor="t"/>
-          <a:lstStyle/>
-          <a:p>
-            <a:pPr indent="0" marL="0">
-              <a:buNone/>
-            </a:pPr>
-            <a:r>
-              <a:rPr lang="en-US" sz="2200" b="1" dirty="0">
-                <a:solidFill>
-                  <a:srgbClr val="035591"/>
-                </a:solidFill>
-              </a:rPr>
-              <a:t>Weg A · Referat</a:t>
-            </a:r>
-            <a:endParaRPr lang="en-US" sz="2200" dirty="0"/>
-          </a:p>
-          <a:p>
-            <a:pPr indent="0" marL="0">
-              <a:spcBef>
-                <a:spcPts val="400"/>
-              </a:spcBef>
-              <a:buNone/>
-            </a:pPr>
-            <a:r>
-              <a:rPr lang="en-US" sz="1900" dirty="0">
-                <a:solidFill>
-                  <a:srgbClr val="14232F"/>
-                </a:solidFill>
-              </a:rPr>
-              <a:t>Ausarbeitung mit Diskussionsergebnissen und Ausblick (über 10 Seiten) – Abgabe zum Ende des Semesters</a:t>
-            </a:r>
-            <a:endParaRPr lang="en-US" sz="2200" dirty="0"/>
-          </a:p>
-        </p:txBody>
-      </p:sp>
-      <p:sp>
-        <p:nvSpPr>
-          <p:cNvPr id="4" name="tile-297"/>
-          <p:cNvSpPr txBox="1"/>
-          <p:nvPr/>
-        </p:nvSpPr>
-        <p:spPr>
-          <a:xfrm>
-            <a:off x="6199632" y="1600200"/>
-            <a:ext cx="5440680" cy="2011680"/>
-          </a:xfrm>
-          <a:prstGeom prst="rect">
-            <a:avLst/>
-          </a:prstGeom>
-          <a:solidFill>
-            <a:srgbClr val="E2F4E8"/>
-          </a:solidFill>
-          <a:ln w="6350">
-            <a:solidFill>
-              <a:srgbClr val="E2F4E8"/>
-            </a:solidFill>
-          </a:ln>
-        </p:spPr>
-        <p:txBody>
-          <a:bodyPr wrap="square" lIns="127000" tIns="127000" rIns="127000" bIns="127000" rtlCol="0" anchor="t"/>
-          <a:lstStyle/>
-          <a:p>
-            <a:pPr indent="0" marL="0">
-              <a:buNone/>
-            </a:pPr>
-            <a:r>
-              <a:rPr lang="en-US" sz="2200" b="1" dirty="0">
-                <a:solidFill>
-                  <a:srgbClr val="035591"/>
-                </a:solidFill>
-              </a:rPr>
-              <a:t>Weg B · Vortrag</a:t>
-            </a:r>
-            <a:endParaRPr lang="en-US" sz="2200" dirty="0"/>
-          </a:p>
-          <a:p>
-            <a:pPr indent="0" marL="0">
-              <a:spcBef>
-                <a:spcPts val="400"/>
-              </a:spcBef>
-              <a:buNone/>
-            </a:pPr>
-            <a:r>
-              <a:rPr lang="en-US" sz="1900" dirty="0">
-                <a:solidFill>
-                  <a:srgbClr val="14232F"/>
-                </a:solidFill>
-              </a:rPr>
-              <a:t>keine Ausarbeitung – Diskussionsergebnisse kurz festhalten</a:t>
-            </a:r>
-            <a:endParaRPr lang="en-US" sz="2200" dirty="0"/>
-          </a:p>
-        </p:txBody>
-      </p:sp>
-      <p:sp>
-        <p:nvSpPr>
-          <p:cNvPr id="5" name="link-298"/>
-          <p:cNvSpPr txBox="1"/>
-          <p:nvPr/>
-        </p:nvSpPr>
-        <p:spPr>
-          <a:xfrm>
-            <a:off x="548640" y="3931920"/>
-            <a:ext cx="7132320" cy="640080"/>
+            <a:off x="822960" y="4480560"/>
+            <a:ext cx="10607040" cy="731520"/>
           </a:xfrm>
           <a:prstGeom prst="rect">
             <a:avLst/>
@@ -6001,60 +7374,6 @@
           <a:ln/>
         </p:spPr>
         <p:txBody>
-          <a:bodyPr wrap="square" lIns="38100" tIns="38100" rIns="38100" bIns="38100" rtlCol="0" anchor="ctr"/>
-          <a:lstStyle/>
-          <a:p>
-            <a:pPr indent="0" marL="0">
-              <a:buNone/>
-            </a:pPr>
-            <a:r>
-              <a:rPr lang="en-US" sz="3000" dirty="0">
-                <a:solidFill>
-                  <a:srgbClr val="14232F"/>
-                </a:solidFill>
-              </a:rPr>
-              <a:t>Kursseite: </a:t>
-            </a:r>
-            <a:pPr indent="0" marL="0">
-              <a:buNone/>
-            </a:pPr>
-            <a:r>
-              <a:rPr lang="en-US" sz="3000" b="1" u="sng" dirty="0">
-                <a:solidFill>
-                  <a:srgbClr val="035591"/>
-                </a:solidFill>
-                <a:hlinkClick r:id="rId1" invalidUrl="" action="" tgtFrame="" tooltip="" history="1" highlightClick="0" endSnd="0">
-                  <a:extLst>
-                    <a:ext uri="{A12FA001-AC4F-418D-AE19-62706E023703}">
-                      <ahyp:hlinkClr xmlns:ahyp="http://schemas.microsoft.com/office/drawing/2018/hyperlinkcolor" val="tx"/>
-                    </a:ext>
-                  </a:extLst>
-                </a:hlinkClick>
-              </a:rPr>
-              <a:t>https://t1p.de/tdk-26</a:t>
-            </a:r>
-            <a:endParaRPr lang="en-US" sz="3000" dirty="0"/>
-          </a:p>
-        </p:txBody>
-      </p:sp>
-      <p:sp>
-        <p:nvSpPr>
-          <p:cNvPr id="6" name="text-299"/>
-          <p:cNvSpPr txBox="1"/>
-          <p:nvPr/>
-        </p:nvSpPr>
-        <p:spPr>
-          <a:xfrm>
-            <a:off x="548640" y="4663440"/>
-            <a:ext cx="7132320" cy="822960"/>
-          </a:xfrm>
-          <a:prstGeom prst="rect">
-            <a:avLst/>
-          </a:prstGeom>
-          <a:noFill/>
-          <a:ln/>
-        </p:spPr>
-        <p:txBody>
           <a:bodyPr wrap="square" lIns="38100" tIns="38100" rIns="38100" bIns="38100" rtlCol="0" anchor="t"/>
           <a:lstStyle/>
           <a:p>
@@ -6062,83 +7381,14 @@
               <a:buNone/>
             </a:pPr>
             <a:r>
-              <a:rPr lang="en-US" sz="2000" dirty="0">
-                <a:solidFill>
-                  <a:srgbClr val="14232F"/>
-                </a:solidFill>
-              </a:rPr>
-              <a:t>Aufgabenpaket 4: Diskussionsergebnisse, Ausblick, Gliederung</a:t>
-            </a:r>
-            <a:endParaRPr lang="en-US" sz="2000" dirty="0"/>
-          </a:p>
-        </p:txBody>
-      </p:sp>
-      <p:pic>
-        <p:nvPicPr>
-          <p:cNvPr id="7" name="qr-300" descr="QR-Code zur Kursseite: https://t1p.de/tdk-26">    </p:cNvPr>
-          <p:cNvPicPr>
-            <a:picLocks noChangeAspect="1"/>
-          </p:cNvPicPr>
-          <p:nvPr/>
-        </p:nvPicPr>
-        <p:blipFill>
-          <a:blip r:embed="rId2"/>
-          <a:stretch>
-            <a:fillRect/>
-          </a:stretch>
-        </p:blipFill>
-        <p:spPr>
-          <a:xfrm>
-            <a:off x="9098280" y="3703320"/>
-            <a:ext cx="2103120" cy="2103120"/>
-          </a:xfrm>
-          <a:prstGeom prst="rect">
-            <a:avLst/>
-          </a:prstGeom>
-        </p:spPr>
-      </p:pic>
-      <p:sp>
-        <p:nvSpPr>
-          <p:cNvPr id="25" name="Slide Number Placeholder 0"/>
-          <p:cNvSpPr>
-            <a:spLocks noGrp="1"/>
-          </p:cNvSpPr>
-          <p:nvPr>
-            <p:ph type="sldNum" sz="quarter" idx="4294967295"/>
-          </p:nvPr>
-        </p:nvSpPr>
-        <p:spPr>
-          <a:xfrm>
-            <a:off x="11247120" y="6473952"/>
-            <a:ext cx="548640" cy="274320"/>
-          </a:xfrm>
-          <a:prstGeom prst="rect">
-            <a:avLst/>
-          </a:prstGeom>
-          <a:extLst>
-            <a:ext uri="{C572A759-6A51-4108-AA02-DFA0A04FC94B}">
-              <ma14:wrappingTextBoxFlag xmlns:ma14="http://schemas.microsoft.com/office/mac/drawingml/2011/main" val="0"/>
-            </a:ext>
-          </a:extLst>
-        </p:spPr>
-        <p:txBody>
-          <a:bodyPr/>
-          <a:lstStyle>
-            <a:lvl1pPr>
-              <a:defRPr sz="1000">
+              <a:rPr lang="en-US" sz="2600" dirty="0">
                 <a:solidFill>
                   <a:srgbClr val="56687A"/>
                 </a:solidFill>
-              </a:defRPr>
-            </a:lvl1pPr>
-          </a:lstStyle>
-          <a:p>
-            <a:pPr algn="r"/>
-            <a:fld id="{F7021451-1387-4CA6-816F-3879F97B5CBC}" type="slidenum">
-              <a:rPr b="0" lang="en-US"/>
-              <a:t>7</a:t>
-            </a:fld>
-            <a:endParaRPr lang="en-US"/>
+              </a:rPr>
+              <a:t>Zu Hause bearbeiten · bis zum Ende des Semesters</a:t>
+            </a:r>
+            <a:endParaRPr lang="en-US" sz="2600" dirty="0"/>
           </a:p>
         </p:txBody>
       </p:sp>

</xml_diff>